<commit_message>
docs(pptx): corrigir verbos remanescentes em 3ª pessoa do singular
Slide "O que validamos na última reunião" tinha bullets em 3ª pessoa
do singular (Concordou/Validou/Entendeu) — orientador como sujeito
implícito. Reescritos para 1ª pessoa do plural, coerente com a nova
voz coletiva da apresentação.

- "Concordou que a evolução..." → "Concordamos que a evolução..."
- "Validou que o SOTA..." → "Validamos que o SOTA..."
- "Entendeu e validou a linha..." → "Alinhamos e validamos a linha..."

Co-Authored-By: Claude Opus 4.7 <noreply@anthropic.com>
</commit_message>
<xml_diff>
--- a/docs/ativo/material_reuniao_orientador_v3.2.1.pptx
+++ b/docs/ativo/material_reuniao_orientador_v3.2.1.pptx
@@ -9498,7 +9498,7 @@
               </a:defRPr>
             </a:pPr>
             <a:r>
-              <a:t>✓  Concordou que a evolução metodológica melhorou significativamente</a:t>
+              <a:t>✓  Concordamos que a evolução metodológica melhorou significativamente</a:t>
             </a:r>
           </a:p>
           <a:p>
@@ -9525,7 +9525,7 @@
               </a:defRPr>
             </a:pPr>
             <a:r>
-              <a:t>✓  Validou que o SOTA encontrado (FaceScanPaliGemma 75.7% F1) é mesmo o atual</a:t>
+              <a:t>✓  Validamos que o SOTA encontrado (FaceScanPaliGemma 75.7% F1) é mesmo o atual</a:t>
             </a:r>
           </a:p>
           <a:p>
@@ -9552,7 +9552,7 @@
               </a:defRPr>
             </a:pPr>
             <a:r>
-              <a:t>✓  Entendeu e validou a linha de pesquisa proposta</a:t>
+              <a:t>✓  Alinhamos e validamos a linha de pesquisa proposta</a:t>
             </a:r>
           </a:p>
           <a:p>

</xml_diff>

<commit_message>
docs(pptx): enriquecer slide 11 com resumo do pipeline em 6 etapas
Slide "Resposta ao pedido 4: reformular para PRESCRITIVA" estava
visualmente vazio com pouco conteúdo. Adicionado resumo das 6 etapas
do pipeline construtivo:

1. Classificador de tom de pele (MST) — SkinToneNet pré-treinado
2. Auditar FairFace e publicar matriz pública MST × raça
3. Race classifier com tom de pele como contexto (FiLM)
4. Comparar fairness COM vs SEM tom, contra 6 baselines
5. Aplicar pipeline a face recognition (RFW ou BFW)
6. Medir melhora em Black/African e decomposição Latinx

Mantida a mudança central no topo + Q04/Q10 unificados no rodapé.
Footer aponta para Parte 3 onde cada etapa será detalhada com
conceitos explicados.

Co-Authored-By: Claude Opus 4.7 <noreply@anthropic.com>
</commit_message>
<xml_diff>
--- a/docs/ativo/material_reuniao_orientador_v3.2.1.pptx
+++ b/docs/ativo/material_reuniao_orientador_v3.2.1.pptx
@@ -3676,7 +3676,7 @@
               </a:defRPr>
             </a:pPr>
             <a:r>
-              <a:t>Nova versão da tese escrita e disponível.</a:t>
+              <a:t>Mudança central: deixa de ‘decompor o erro’ e passa a ‘construir um pipeline’</a:t>
             </a:r>
           </a:p>
           <a:p>
@@ -3690,6 +3690,9 @@
                 </a:solidFill>
               </a:defRPr>
             </a:pPr>
+            <a:r>
+              <a:t>que melhora fairness em race classification E em face recognition,</a:t>
+            </a:r>
           </a:p>
           <a:p>
             <a:pPr>
@@ -3703,7 +3706,7 @@
               </a:defRPr>
             </a:pPr>
             <a:r>
-              <a:t>Mudança central: deixa de ser ‘decompor o erro’ e passa a ser</a:t>
+              <a:t>usando tom de pele como sinal auxiliar.</a:t>
             </a:r>
           </a:p>
           <a:p>
@@ -3717,9 +3720,6 @@
                 </a:solidFill>
               </a:defRPr>
             </a:pPr>
-            <a:r>
-              <a:t>‘construir um pipeline que melhora fairness em race classification</a:t>
-            </a:r>
           </a:p>
           <a:p>
             <a:pPr>
@@ -3733,7 +3733,97 @@
               </a:defRPr>
             </a:pPr>
             <a:r>
-              <a:t>E em face recognition, usando tom de pele como sinal auxiliar’.</a:t>
+              <a:t>Pipeline construtivo em 6 etapas:</a:t>
+            </a:r>
+          </a:p>
+          <a:p>
+            <a:pPr lvl="1">
+              <a:spcAft>
+                <a:spcPts val="800"/>
+              </a:spcAft>
+              <a:defRPr sz="1700">
+                <a:solidFill>
+                  <a:srgbClr val="707682"/>
+                </a:solidFill>
+              </a:defRPr>
+            </a:pPr>
+            <a:r>
+              <a:t>1. Classificador de tom de pele (MST) — usar SkinToneNet pré-treinado</a:t>
+            </a:r>
+          </a:p>
+          <a:p>
+            <a:pPr lvl="1">
+              <a:spcAft>
+                <a:spcPts val="800"/>
+              </a:spcAft>
+              <a:defRPr sz="1700">
+                <a:solidFill>
+                  <a:srgbClr val="707682"/>
+                </a:solidFill>
+              </a:defRPr>
+            </a:pPr>
+            <a:r>
+              <a:t>2. Auditar FairFace e publicar a matriz pública MST × raça</a:t>
+            </a:r>
+          </a:p>
+          <a:p>
+            <a:pPr lvl="1">
+              <a:spcAft>
+                <a:spcPts val="800"/>
+              </a:spcAft>
+              <a:defRPr sz="1700">
+                <a:solidFill>
+                  <a:srgbClr val="707682"/>
+                </a:solidFill>
+              </a:defRPr>
+            </a:pPr>
+            <a:r>
+              <a:t>3. Race classifier com tom de pele como contexto (mecanismo FiLM)</a:t>
+            </a:r>
+          </a:p>
+          <a:p>
+            <a:pPr lvl="1">
+              <a:spcAft>
+                <a:spcPts val="800"/>
+              </a:spcAft>
+              <a:defRPr sz="1700">
+                <a:solidFill>
+                  <a:srgbClr val="707682"/>
+                </a:solidFill>
+              </a:defRPr>
+            </a:pPr>
+            <a:r>
+              <a:t>4. Comparar fairness COM vs SEM tom de pele, contra 6 baselines</a:t>
+            </a:r>
+          </a:p>
+          <a:p>
+            <a:pPr lvl="1">
+              <a:spcAft>
+                <a:spcPts val="800"/>
+              </a:spcAft>
+              <a:defRPr sz="1700">
+                <a:solidFill>
+                  <a:srgbClr val="707682"/>
+                </a:solidFill>
+              </a:defRPr>
+            </a:pPr>
+            <a:r>
+              <a:t>5. Aplicar pipeline a face recognition (RFW ou BFW)</a:t>
+            </a:r>
+          </a:p>
+          <a:p>
+            <a:pPr lvl="1">
+              <a:spcAft>
+                <a:spcPts val="800"/>
+              </a:spcAft>
+              <a:defRPr sz="1700">
+                <a:solidFill>
+                  <a:srgbClr val="707682"/>
+                </a:solidFill>
+              </a:defRPr>
+            </a:pPr>
+            <a:r>
+              <a:t>6. Medir melhora em Black/African e decomposição Latinx</a:t>
             </a:r>
           </a:p>
           <a:p>
@@ -3760,49 +3850,42 @@
               </a:defRPr>
             </a:pPr>
             <a:r>
-              <a:t>Q04 (mitigação) e Q10 (matriz tom × raça) deixam de ser capítulos</a:t>
-            </a:r>
-          </a:p>
-          <a:p>
-            <a:pPr>
-              <a:spcAft>
-                <a:spcPts val="800"/>
-              </a:spcAft>
-              <a:defRPr sz="2000" b="0">
-                <a:solidFill>
-                  <a:srgbClr val="3D424E"/>
-                </a:solidFill>
-              </a:defRPr>
-            </a:pPr>
-            <a:r>
-              <a:t>paralelos e viram pipeline UNIFICADO.</a:t>
-            </a:r>
-          </a:p>
-          <a:p>
-            <a:pPr>
-              <a:spcAft>
-                <a:spcPts val="800"/>
-              </a:spcAft>
-              <a:defRPr sz="2000" b="0">
-                <a:solidFill>
-                  <a:srgbClr val="3D424E"/>
-                </a:solidFill>
-              </a:defRPr>
-            </a:pPr>
-          </a:p>
-          <a:p>
-            <a:pPr>
-              <a:spcAft>
-                <a:spcPts val="800"/>
-              </a:spcAft>
-              <a:defRPr sz="2000" b="0">
-                <a:solidFill>
-                  <a:srgbClr val="3D424E"/>
-                </a:solidFill>
-              </a:defRPr>
-            </a:pPr>
-            <a:r>
-              <a:t>Vou detalhar a nova tese na Parte 3 desta apresentação.</a:t>
+              <a:t>Q04 (mitigação) e Q10 (matriz tom × raça) viram pipeline UNIFICADO.</a:t>
+            </a:r>
+          </a:p>
+        </p:txBody>
+      </p:sp>
+      <p:sp>
+        <p:nvSpPr>
+          <p:cNvPr id="5" name="TextBox 4"/>
+          <p:cNvSpPr txBox="1"/>
+          <p:nvPr/>
+        </p:nvSpPr>
+        <p:spPr>
+          <a:xfrm>
+            <a:off x="457200" y="6400800"/>
+            <a:ext cx="11430000" cy="365760"/>
+          </a:xfrm>
+          <a:prstGeom prst="rect">
+            <a:avLst/>
+          </a:prstGeom>
+          <a:noFill/>
+        </p:spPr>
+        <p:txBody>
+          <a:bodyPr wrap="none">
+            <a:spAutoFit/>
+          </a:bodyPr>
+          <a:lstStyle/>
+          <a:p>
+            <a:pPr>
+              <a:defRPr sz="1500" i="1">
+                <a:solidFill>
+                  <a:srgbClr val="707682"/>
+                </a:solidFill>
+              </a:defRPr>
+            </a:pPr>
+            <a:r>
+              <a:t>Cada etapa será detalhada com conceitos explicados na Parte 3</a:t>
             </a:r>
           </a:p>
         </p:txBody>

</xml_diff>

<commit_message>
docs(pptx): slide 4 — listar os 6 tracks temáticos do corpus
No slide "Como a tese estava na última reunião", a menção a "6 tracks
temáticos" virou listagem explícita:
- Track A: Race classification (alvo direto)
- Track B: Face recognition fairness (paralelo)
- Track C: Skin tone como dimensão alternativa
- Track D: Mitigação algorítmica (técnicas)
- Track E: Auditoria e metodologia
- Track F: Fundamentação científica de raça e tom de pele

Track G (Mecanismos ML/RN) foi adicionado na Rodada 5, então não
aparece aqui — coerente com o estado do corpus na última reunião.

Co-Authored-By: Claude Opus 4.7 <noreply@anthropic.com>
</commit_message>
<xml_diff>
--- a/docs/ativo/material_reuniao_orientador_v3.2.1.pptx
+++ b/docs/ativo/material_reuniao_orientador_v3.2.1.pptx
@@ -11047,7 +11047,97 @@
               </a:defRPr>
             </a:pPr>
             <a:r>
-              <a:t>Corpus naquele momento: 23 fichas catalogadas, 6 tracks temáticos.</a:t>
+              <a:t>Corpus naquele momento: 23 fichas catalogadas em 6 tracks temáticos:</a:t>
+            </a:r>
+          </a:p>
+          <a:p>
+            <a:pPr lvl="1">
+              <a:spcAft>
+                <a:spcPts val="800"/>
+              </a:spcAft>
+              <a:defRPr sz="1700">
+                <a:solidFill>
+                  <a:srgbClr val="707682"/>
+                </a:solidFill>
+              </a:defRPr>
+            </a:pPr>
+            <a:r>
+              <a:t>Track A — Race classification (alvo direto da dissertação)</a:t>
+            </a:r>
+          </a:p>
+          <a:p>
+            <a:pPr lvl="1">
+              <a:spcAft>
+                <a:spcPts val="800"/>
+              </a:spcAft>
+              <a:defRPr sz="1700">
+                <a:solidFill>
+                  <a:srgbClr val="707682"/>
+                </a:solidFill>
+              </a:defRPr>
+            </a:pPr>
+            <a:r>
+              <a:t>Track B — Face recognition fairness (paralelo)</a:t>
+            </a:r>
+          </a:p>
+          <a:p>
+            <a:pPr lvl="1">
+              <a:spcAft>
+                <a:spcPts val="800"/>
+              </a:spcAft>
+              <a:defRPr sz="1700">
+                <a:solidFill>
+                  <a:srgbClr val="707682"/>
+                </a:solidFill>
+              </a:defRPr>
+            </a:pPr>
+            <a:r>
+              <a:t>Track C — Skin tone como dimensão alternativa</a:t>
+            </a:r>
+          </a:p>
+          <a:p>
+            <a:pPr lvl="1">
+              <a:spcAft>
+                <a:spcPts val="800"/>
+              </a:spcAft>
+              <a:defRPr sz="1700">
+                <a:solidFill>
+                  <a:srgbClr val="707682"/>
+                </a:solidFill>
+              </a:defRPr>
+            </a:pPr>
+            <a:r>
+              <a:t>Track D — Mitigação algorítmica (técnicas)</a:t>
+            </a:r>
+          </a:p>
+          <a:p>
+            <a:pPr lvl="1">
+              <a:spcAft>
+                <a:spcPts val="800"/>
+              </a:spcAft>
+              <a:defRPr sz="1700">
+                <a:solidFill>
+                  <a:srgbClr val="707682"/>
+                </a:solidFill>
+              </a:defRPr>
+            </a:pPr>
+            <a:r>
+              <a:t>Track E — Auditoria e metodologia</a:t>
+            </a:r>
+          </a:p>
+          <a:p>
+            <a:pPr lvl="1">
+              <a:spcAft>
+                <a:spcPts val="800"/>
+              </a:spcAft>
+              <a:defRPr sz="1700">
+                <a:solidFill>
+                  <a:srgbClr val="707682"/>
+                </a:solidFill>
+              </a:defRPr>
+            </a:pPr>
+            <a:r>
+              <a:t>Track F — Fundamentação científica de raça e tom de pele</a:t>
             </a:r>
           </a:p>
         </p:txBody>

</xml_diff>

<commit_message>
docs: ajustes manuais no PPTX + ignorar arquivos lock do Office
- PPTX atualizado com ajustes manuais aplicados pelo usuário
  diretamente no PowerPoint.
- .gitignore: adicionada regra '~$*' para ignorar arquivos
  temporários do Microsoft Office (criados enquanto arquivos
  estão abertos), evitando que poluam o repositório.

Co-Authored-By: Claude Opus 4.7 <noreply@anthropic.com>
</commit_message>
<xml_diff>
--- a/docs/ativo/material_reuniao_orientador_v3.2.1.pptx
+++ b/docs/ativo/material_reuniao_orientador_v3.2.1.pptx
@@ -5,7 +5,7 @@
     <p:sldMasterId id="2147483648" r:id="rId1"/>
   </p:sldMasterIdLst>
   <p:notesMasterIdLst>
-    <p:notesMasterId r:id="rId34"/>
+    <p:notesMasterId r:id="rId35"/>
   </p:notesMasterIdLst>
   <p:sldIdLst>
     <p:sldId id="256" r:id="rId2"/>
@@ -40,6 +40,7 @@
     <p:sldId id="285" r:id="rId31"/>
     <p:sldId id="286" r:id="rId32"/>
     <p:sldId id="287" r:id="rId33"/>
+    <p:sldId id="288" r:id="rId34"/>
   </p:sldIdLst>
   <p:sldSz cx="12192000" cy="6858000"/>
   <p:notesSz cx="6858000" cy="9144000"/>
@@ -239,7 +240,7 @@
           <a:p>
             <a:fld id="{A39808EF-15CC-40CF-A5B5-88E8128F5D8F}" type="datetimeFigureOut">
               <a:rPr lang="pt-BR" smtClean="0"/>
-              <a:t>08/06/2026</a:t>
+              <a:t>09/06/2026</a:t>
             </a:fld>
             <a:endParaRPr lang="pt-BR"/>
           </a:p>
@@ -550,10 +551,55 @@
           <a:bodyPr/>
           <a:lstStyle/>
           <a:p>
-            <a:r>
-              <a:rPr lang="pt-BR" dirty="0"/>
-              <a:t>Em outras palavras: o tom de pele é informação que o classificador de raça precisa ter explicitamente — não pode descobrir sozinho.</a:t>
-            </a:r>
+            <a:pPr>
+              <a:spcAft>
+                <a:spcPts val="800"/>
+              </a:spcAft>
+              <a:defRPr sz="2000" b="0">
+                <a:solidFill>
+                  <a:srgbClr val="3D424E"/>
+                </a:solidFill>
+              </a:defRPr>
+            </a:pPr>
+            <a:r>
+              <a:rPr lang="pt-BR" i="1" dirty="0"/>
+              <a:t>Observações:</a:t>
+            </a:r>
+          </a:p>
+          <a:p>
+            <a:pPr>
+              <a:spcAft>
+                <a:spcPts val="800"/>
+              </a:spcAft>
+              <a:defRPr sz="2000" b="0">
+                <a:solidFill>
+                  <a:srgbClr val="3D424E"/>
+                </a:solidFill>
+              </a:defRPr>
+            </a:pPr>
+            <a:r>
+              <a:rPr lang="pt-BR" i="1" dirty="0"/>
+              <a:t>- Adicionada nas 10 fichas centrais (lista de leitura prioritária).</a:t>
+            </a:r>
+          </a:p>
+          <a:p>
+            <a:pPr>
+              <a:spcAft>
+                <a:spcPts val="800"/>
+              </a:spcAft>
+              <a:defRPr sz="2000" b="0">
+                <a:solidFill>
+                  <a:srgbClr val="3D424E"/>
+                </a:solidFill>
+              </a:defRPr>
+            </a:pPr>
+            <a:r>
+              <a:rPr lang="pt-BR" i="1" dirty="0"/>
+              <a:t>- Vamos expandir para as outras 19 após aprovação conjunta da nova versão da tese.</a:t>
+            </a:r>
+          </a:p>
+          <a:p>
+            <a:endParaRPr lang="pt-BR" dirty="0"/>
           </a:p>
         </p:txBody>
       </p:sp>
@@ -574,7 +620,7 @@
           <a:p>
             <a:fld id="{EE54A5EC-A2C7-4FB7-A8D7-6AC4B741C566}" type="slidenum">
               <a:rPr lang="pt-BR" smtClean="0"/>
-              <a:t>13</a:t>
+              <a:t>8</a:t>
             </a:fld>
             <a:endParaRPr lang="pt-BR"/>
           </a:p>
@@ -583,7 +629,7 @@
     </p:spTree>
     <p:extLst>
       <p:ext uri="{BB962C8B-B14F-4D97-AF65-F5344CB8AC3E}">
-        <p14:creationId xmlns:p14="http://schemas.microsoft.com/office/powerpoint/2010/main" val="2805461471"/>
+        <p14:creationId xmlns:p14="http://schemas.microsoft.com/office/powerpoint/2010/main" val="1096554398"/>
       </p:ext>
     </p:extLst>
   </p:cSld>
@@ -612,6 +658,93 @@
       </p:grpSpPr>
       <p:sp>
         <p:nvSpPr>
+          <p:cNvPr id="2" name="Espaço Reservado para Imagem de Slide 1"/>
+          <p:cNvSpPr>
+            <a:spLocks noGrp="1" noRot="1" noChangeAspect="1"/>
+          </p:cNvSpPr>
+          <p:nvPr>
+            <p:ph type="sldImg"/>
+          </p:nvPr>
+        </p:nvSpPr>
+        <p:spPr/>
+      </p:sp>
+      <p:sp>
+        <p:nvSpPr>
+          <p:cNvPr id="3" name="Espaço Reservado para Anotações 2"/>
+          <p:cNvSpPr>
+            <a:spLocks noGrp="1"/>
+          </p:cNvSpPr>
+          <p:nvPr>
+            <p:ph type="body" idx="1"/>
+          </p:nvPr>
+        </p:nvSpPr>
+        <p:spPr/>
+        <p:txBody>
+          <a:bodyPr/>
+          <a:lstStyle/>
+          <a:p>
+            <a:r>
+              <a:rPr lang="pt-BR" dirty="0"/>
+              <a:t>Em outras palavras: o tom de pele é informação que o classificador de raça precisa ter explicitamente — não pode descobrir sozinho.</a:t>
+            </a:r>
+          </a:p>
+        </p:txBody>
+      </p:sp>
+      <p:sp>
+        <p:nvSpPr>
+          <p:cNvPr id="4" name="Espaço Reservado para Número de Slide 3"/>
+          <p:cNvSpPr>
+            <a:spLocks noGrp="1"/>
+          </p:cNvSpPr>
+          <p:nvPr>
+            <p:ph type="sldNum" sz="quarter" idx="5"/>
+          </p:nvPr>
+        </p:nvSpPr>
+        <p:spPr/>
+        <p:txBody>
+          <a:bodyPr/>
+          <a:lstStyle/>
+          <a:p>
+            <a:fld id="{EE54A5EC-A2C7-4FB7-A8D7-6AC4B741C566}" type="slidenum">
+              <a:rPr lang="pt-BR" smtClean="0"/>
+              <a:t>13</a:t>
+            </a:fld>
+            <a:endParaRPr lang="pt-BR"/>
+          </a:p>
+        </p:txBody>
+      </p:sp>
+    </p:spTree>
+    <p:extLst>
+      <p:ext uri="{BB962C8B-B14F-4D97-AF65-F5344CB8AC3E}">
+        <p14:creationId xmlns:p14="http://schemas.microsoft.com/office/powerpoint/2010/main" val="2805461471"/>
+      </p:ext>
+    </p:extLst>
+  </p:cSld>
+  <p:clrMapOvr>
+    <a:masterClrMapping/>
+  </p:clrMapOvr>
+</p:notes>
+</file>
+
+<file path=ppt/notesSlides/notesSlide3.xml><?xml version="1.0" encoding="utf-8"?>
+<p:notes xmlns:a="http://schemas.openxmlformats.org/drawingml/2006/main" xmlns:r="http://schemas.openxmlformats.org/officeDocument/2006/relationships" xmlns:p="http://schemas.openxmlformats.org/presentationml/2006/main">
+  <p:cSld>
+    <p:spTree>
+      <p:nvGrpSpPr>
+        <p:cNvPr id="1" name=""/>
+        <p:cNvGrpSpPr/>
+        <p:nvPr/>
+      </p:nvGrpSpPr>
+      <p:grpSpPr>
+        <a:xfrm>
+          <a:off x="0" y="0"/>
+          <a:ext cx="0" cy="0"/>
+          <a:chOff x="0" y="0"/>
+          <a:chExt cx="0" cy="0"/>
+        </a:xfrm>
+      </p:grpSpPr>
+      <p:sp>
+        <p:nvSpPr>
           <p:cNvPr id="2" name="Slide Image Placeholder 1"/>
           <p:cNvSpPr>
             <a:spLocks noGrp="1" noRot="1" noChangeAspect="1"/>
@@ -687,7 +820,7 @@
 </p:notes>
 </file>
 
-<file path=ppt/notesSlides/notesSlide3.xml><?xml version="1.0" encoding="utf-8"?>
+<file path=ppt/notesSlides/notesSlide4.xml><?xml version="1.0" encoding="utf-8"?>
 <p:notes xmlns:a="http://schemas.openxmlformats.org/drawingml/2006/main" xmlns:r="http://schemas.openxmlformats.org/officeDocument/2006/relationships" xmlns:p="http://schemas.openxmlformats.org/presentationml/2006/main">
   <p:cSld>
     <p:spTree>
@@ -1502,7 +1635,7 @@
           <a:p>
             <a:fld id="{5BCAD085-E8A6-8845-BD4E-CB4CCA059FC4}" type="datetimeFigureOut">
               <a:rPr lang="en-US" smtClean="0"/>
-              <a:t>6/8/2026</a:t>
+              <a:t>6/9/2026</a:t>
             </a:fld>
             <a:endParaRPr lang="en-US"/>
           </a:p>
@@ -1670,7 +1803,7 @@
           <a:p>
             <a:fld id="{5BCAD085-E8A6-8845-BD4E-CB4CCA059FC4}" type="datetimeFigureOut">
               <a:rPr lang="en-US" smtClean="0"/>
-              <a:t>6/8/2026</a:t>
+              <a:t>6/9/2026</a:t>
             </a:fld>
             <a:endParaRPr lang="en-US"/>
           </a:p>
@@ -1848,7 +1981,7 @@
           <a:p>
             <a:fld id="{5BCAD085-E8A6-8845-BD4E-CB4CCA059FC4}" type="datetimeFigureOut">
               <a:rPr lang="en-US" smtClean="0"/>
-              <a:t>6/8/2026</a:t>
+              <a:t>6/9/2026</a:t>
             </a:fld>
             <a:endParaRPr lang="en-US"/>
           </a:p>
@@ -2016,7 +2149,7 @@
           <a:p>
             <a:fld id="{5BCAD085-E8A6-8845-BD4E-CB4CCA059FC4}" type="datetimeFigureOut">
               <a:rPr lang="en-US" smtClean="0"/>
-              <a:t>6/8/2026</a:t>
+              <a:t>6/9/2026</a:t>
             </a:fld>
             <a:endParaRPr lang="en-US"/>
           </a:p>
@@ -2261,7 +2394,7 @@
           <a:p>
             <a:fld id="{5BCAD085-E8A6-8845-BD4E-CB4CCA059FC4}" type="datetimeFigureOut">
               <a:rPr lang="en-US" smtClean="0"/>
-              <a:t>6/8/2026</a:t>
+              <a:t>6/9/2026</a:t>
             </a:fld>
             <a:endParaRPr lang="en-US"/>
           </a:p>
@@ -2546,7 +2679,7 @@
           <a:p>
             <a:fld id="{5BCAD085-E8A6-8845-BD4E-CB4CCA059FC4}" type="datetimeFigureOut">
               <a:rPr lang="en-US" smtClean="0"/>
-              <a:t>6/8/2026</a:t>
+              <a:t>6/9/2026</a:t>
             </a:fld>
             <a:endParaRPr lang="en-US"/>
           </a:p>
@@ -2965,7 +3098,7 @@
           <a:p>
             <a:fld id="{5BCAD085-E8A6-8845-BD4E-CB4CCA059FC4}" type="datetimeFigureOut">
               <a:rPr lang="en-US" smtClean="0"/>
-              <a:t>6/8/2026</a:t>
+              <a:t>6/9/2026</a:t>
             </a:fld>
             <a:endParaRPr lang="en-US"/>
           </a:p>
@@ -3082,7 +3215,7 @@
           <a:p>
             <a:fld id="{5BCAD085-E8A6-8845-BD4E-CB4CCA059FC4}" type="datetimeFigureOut">
               <a:rPr lang="en-US" smtClean="0"/>
-              <a:t>6/8/2026</a:t>
+              <a:t>6/9/2026</a:t>
             </a:fld>
             <a:endParaRPr lang="en-US"/>
           </a:p>
@@ -3177,7 +3310,7 @@
           <a:p>
             <a:fld id="{5BCAD085-E8A6-8845-BD4E-CB4CCA059FC4}" type="datetimeFigureOut">
               <a:rPr lang="en-US" smtClean="0"/>
-              <a:t>6/8/2026</a:t>
+              <a:t>6/9/2026</a:t>
             </a:fld>
             <a:endParaRPr lang="en-US"/>
           </a:p>
@@ -3452,7 +3585,7 @@
           <a:p>
             <a:fld id="{5BCAD085-E8A6-8845-BD4E-CB4CCA059FC4}" type="datetimeFigureOut">
               <a:rPr lang="en-US" smtClean="0"/>
-              <a:t>6/8/2026</a:t>
+              <a:t>6/9/2026</a:t>
             </a:fld>
             <a:endParaRPr lang="en-US"/>
           </a:p>
@@ -3704,7 +3837,7 @@
           <a:p>
             <a:fld id="{5BCAD085-E8A6-8845-BD4E-CB4CCA059FC4}" type="datetimeFigureOut">
               <a:rPr lang="en-US" smtClean="0"/>
-              <a:t>6/8/2026</a:t>
+              <a:t>6/9/2026</a:t>
             </a:fld>
             <a:endParaRPr lang="en-US"/>
           </a:p>
@@ -3915,7 +4048,7 @@
           <a:p>
             <a:fld id="{5BCAD085-E8A6-8845-BD4E-CB4CCA059FC4}" type="datetimeFigureOut">
               <a:rPr lang="en-US" smtClean="0"/>
-              <a:t>6/8/2026</a:t>
+              <a:t>6/9/2026</a:t>
             </a:fld>
             <a:endParaRPr lang="en-US"/>
           </a:p>
@@ -5170,7 +5303,7 @@
         <p:spPr>
           <a:xfrm>
             <a:off x="548640" y="1371600"/>
-            <a:ext cx="11247120" cy="3908762"/>
+            <a:ext cx="11247120" cy="3088025"/>
           </a:xfrm>
           <a:prstGeom prst="rect">
             <a:avLst/>
@@ -5206,12 +5339,12 @@
               <a:t>, </a:t>
             </a:r>
             <a:r>
-              <a:rPr dirty="0" err="1"/>
-              <a:t>aprovamos</a:t>
-            </a:r>
-            <a:r>
-              <a:rPr dirty="0"/>
-              <a:t> 29 </a:t>
+              <a:rPr lang="pt-BR" dirty="0"/>
+              <a:t>30 foram considerados</a:t>
+            </a:r>
+            <a:r>
+              <a:rPr dirty="0"/>
+              <a:t> </a:t>
             </a:r>
             <a:r>
               <a:rPr dirty="0" err="1"/>
@@ -5502,91 +5635,6 @@
               </a:defRPr>
             </a:pPr>
             <a:endParaRPr lang="pt-BR" dirty="0"/>
-          </a:p>
-          <a:p>
-            <a:pPr>
-              <a:spcAft>
-                <a:spcPts val="800"/>
-              </a:spcAft>
-              <a:defRPr sz="2000" b="0">
-                <a:solidFill>
-                  <a:srgbClr val="3D424E"/>
-                </a:solidFill>
-              </a:defRPr>
-            </a:pPr>
-            <a:r>
-              <a:rPr lang="pt-BR" i="1" dirty="0"/>
-              <a:t>Observação:</a:t>
-            </a:r>
-            <a:endParaRPr i="1" dirty="0"/>
-          </a:p>
-          <a:p>
-            <a:pPr>
-              <a:spcAft>
-                <a:spcPts val="800"/>
-              </a:spcAft>
-              <a:defRPr sz="2000" b="0">
-                <a:solidFill>
-                  <a:srgbClr val="3D424E"/>
-                </a:solidFill>
-              </a:defRPr>
-            </a:pPr>
-            <a:r>
-              <a:rPr lang="pt-BR" i="1" dirty="0"/>
-              <a:t>- </a:t>
-            </a:r>
-            <a:r>
-              <a:rPr i="1" dirty="0"/>
-              <a:t>Cada </a:t>
-            </a:r>
-            <a:r>
-              <a:rPr i="1" dirty="0" err="1"/>
-              <a:t>decisão</a:t>
-            </a:r>
-            <a:r>
-              <a:rPr i="1" dirty="0"/>
-              <a:t> (</a:t>
-            </a:r>
-            <a:r>
-              <a:rPr i="1" dirty="0" err="1"/>
-              <a:t>aprovado</a:t>
-            </a:r>
-            <a:r>
-              <a:rPr i="1" dirty="0"/>
-              <a:t> / standby / </a:t>
-            </a:r>
-            <a:r>
-              <a:rPr i="1" dirty="0" err="1"/>
-              <a:t>descartado</a:t>
-            </a:r>
-            <a:r>
-              <a:rPr i="1" dirty="0"/>
-              <a:t>) </a:t>
-            </a:r>
-            <a:r>
-              <a:rPr i="1" dirty="0" err="1"/>
-              <a:t>tem</a:t>
-            </a:r>
-            <a:r>
-              <a:rPr i="1" dirty="0"/>
-              <a:t> data e </a:t>
-            </a:r>
-            <a:r>
-              <a:rPr i="1" dirty="0" err="1"/>
-              <a:t>justificativa</a:t>
-            </a:r>
-            <a:r>
-              <a:rPr i="1" dirty="0"/>
-              <a:t> </a:t>
-            </a:r>
-            <a:r>
-              <a:rPr i="1" dirty="0" err="1"/>
-              <a:t>registradas</a:t>
-            </a:r>
-            <a:r>
-              <a:rPr i="1" dirty="0"/>
-              <a:t>.</a:t>
-            </a:r>
           </a:p>
         </p:txBody>
       </p:sp>
@@ -6244,8 +6292,10 @@
               </a:defRPr>
             </a:pPr>
             <a:r>
-              <a:t>Em palavras simples</a:t>
-            </a:r>
+              <a:rPr lang="pt-BR" dirty="0"/>
+              <a:t>Resumo</a:t>
+            </a:r>
+            <a:endParaRPr dirty="0"/>
           </a:p>
           <a:p>
             <a:pPr>
@@ -6256,7 +6306,216 @@
               </a:defRPr>
             </a:pPr>
             <a:r>
-              <a:t>Uma escala de 10 tons de pele (do tom 1 mais claro ao tom 10 mais escuro), criada em 2023 pelo sociólogo Dr. Ellis Monk (Harvard) em parceria com o Google. Foi desenhada especificamente para auditar fairness em sistemas de IA — não é a escala antiga de dermatologia (Fitzpatrick), que tem viés para pele clara.</a:t>
+              <a:rPr dirty="0"/>
+              <a:t>Uma </a:t>
+            </a:r>
+            <a:r>
+              <a:rPr dirty="0" err="1"/>
+              <a:t>escala</a:t>
+            </a:r>
+            <a:r>
+              <a:rPr dirty="0"/>
+              <a:t> de 10 tons de </a:t>
+            </a:r>
+            <a:r>
+              <a:rPr dirty="0" err="1"/>
+              <a:t>pele</a:t>
+            </a:r>
+            <a:r>
+              <a:rPr dirty="0"/>
+              <a:t> (do tom 1 </a:t>
+            </a:r>
+            <a:r>
+              <a:rPr dirty="0" err="1"/>
+              <a:t>mais</a:t>
+            </a:r>
+            <a:r>
+              <a:rPr dirty="0"/>
+              <a:t> claro </a:t>
+            </a:r>
+            <a:r>
+              <a:rPr dirty="0" err="1"/>
+              <a:t>ao</a:t>
+            </a:r>
+            <a:r>
+              <a:rPr dirty="0"/>
+              <a:t> tom 10 </a:t>
+            </a:r>
+            <a:r>
+              <a:rPr dirty="0" err="1"/>
+              <a:t>mais</a:t>
+            </a:r>
+            <a:r>
+              <a:rPr dirty="0"/>
+              <a:t> </a:t>
+            </a:r>
+            <a:r>
+              <a:rPr dirty="0" err="1"/>
+              <a:t>escuro</a:t>
+            </a:r>
+            <a:r>
+              <a:rPr dirty="0"/>
+              <a:t>), </a:t>
+            </a:r>
+            <a:r>
+              <a:rPr dirty="0" err="1"/>
+              <a:t>criada</a:t>
+            </a:r>
+            <a:r>
+              <a:rPr dirty="0"/>
+              <a:t> </a:t>
+            </a:r>
+            <a:r>
+              <a:rPr dirty="0" err="1"/>
+              <a:t>em</a:t>
+            </a:r>
+            <a:r>
+              <a:rPr dirty="0"/>
+              <a:t> 2023 </a:t>
+            </a:r>
+            <a:r>
+              <a:rPr dirty="0" err="1"/>
+              <a:t>pelo</a:t>
+            </a:r>
+            <a:r>
+              <a:rPr dirty="0"/>
+              <a:t> </a:t>
+            </a:r>
+            <a:r>
+              <a:rPr dirty="0" err="1"/>
+              <a:t>sociólogo</a:t>
+            </a:r>
+            <a:r>
+              <a:rPr dirty="0"/>
+              <a:t> Dr. Ellis Monk (Harvard) </a:t>
+            </a:r>
+            <a:r>
+              <a:rPr dirty="0" err="1"/>
+              <a:t>em</a:t>
+            </a:r>
+            <a:r>
+              <a:rPr dirty="0"/>
+              <a:t> </a:t>
+            </a:r>
+            <a:r>
+              <a:rPr dirty="0" err="1"/>
+              <a:t>parceria</a:t>
+            </a:r>
+            <a:r>
+              <a:rPr dirty="0"/>
+              <a:t> com o Google. Foi </a:t>
+            </a:r>
+            <a:r>
+              <a:rPr dirty="0" err="1"/>
+              <a:t>desenhada</a:t>
+            </a:r>
+            <a:r>
+              <a:rPr dirty="0"/>
+              <a:t> </a:t>
+            </a:r>
+            <a:r>
+              <a:rPr dirty="0" err="1"/>
+              <a:t>especificamente</a:t>
+            </a:r>
+            <a:r>
+              <a:rPr dirty="0"/>
+              <a:t> para </a:t>
+            </a:r>
+            <a:r>
+              <a:rPr dirty="0" err="1"/>
+              <a:t>auditar</a:t>
+            </a:r>
+            <a:r>
+              <a:rPr dirty="0"/>
+              <a:t> fairness </a:t>
+            </a:r>
+            <a:r>
+              <a:rPr dirty="0" err="1"/>
+              <a:t>em</a:t>
+            </a:r>
+            <a:r>
+              <a:rPr dirty="0"/>
+              <a:t> </a:t>
+            </a:r>
+            <a:r>
+              <a:rPr dirty="0" err="1"/>
+              <a:t>sistemas</a:t>
+            </a:r>
+            <a:r>
+              <a:rPr dirty="0"/>
+              <a:t> de IA — </a:t>
+            </a:r>
+            <a:r>
+              <a:rPr dirty="0" err="1"/>
+              <a:t>não</a:t>
+            </a:r>
+            <a:r>
+              <a:rPr dirty="0"/>
+              <a:t> é a </a:t>
+            </a:r>
+            <a:r>
+              <a:rPr dirty="0" err="1"/>
+              <a:t>escala</a:t>
+            </a:r>
+            <a:r>
+              <a:rPr dirty="0"/>
+              <a:t> </a:t>
+            </a:r>
+            <a:r>
+              <a:rPr dirty="0" err="1"/>
+              <a:t>antiga</a:t>
+            </a:r>
+            <a:r>
+              <a:rPr dirty="0"/>
+              <a:t> de </a:t>
+            </a:r>
+            <a:r>
+              <a:rPr dirty="0" err="1"/>
+              <a:t>dermatologia</a:t>
+            </a:r>
+            <a:r>
+              <a:rPr dirty="0"/>
+              <a:t> (Fitzpatrick), </a:t>
+            </a:r>
+            <a:r>
+              <a:rPr dirty="0" err="1"/>
+              <a:t>que</a:t>
+            </a:r>
+            <a:r>
+              <a:rPr dirty="0"/>
+              <a:t> </a:t>
+            </a:r>
+            <a:r>
+              <a:rPr dirty="0" err="1"/>
+              <a:t>tem</a:t>
+            </a:r>
+            <a:r>
+              <a:rPr dirty="0"/>
+              <a:t> </a:t>
+            </a:r>
+            <a:r>
+              <a:rPr dirty="0" err="1"/>
+              <a:t>viés</a:t>
+            </a:r>
+            <a:r>
+              <a:rPr dirty="0"/>
+              <a:t> para </a:t>
+            </a:r>
+            <a:r>
+              <a:rPr dirty="0" err="1"/>
+              <a:t>pele</a:t>
+            </a:r>
+            <a:r>
+              <a:rPr dirty="0"/>
+              <a:t> </a:t>
+            </a:r>
+            <a:r>
+              <a:rPr dirty="0" err="1"/>
+              <a:t>clara</a:t>
+            </a:r>
+            <a:r>
+              <a:rPr dirty="0"/>
+              <a:t>.</a:t>
             </a:r>
           </a:p>
         </p:txBody>
@@ -6310,8 +6569,10 @@
               </a:defRPr>
             </a:pPr>
             <a:r>
-              <a:t>Por que importa para a tese</a:t>
-            </a:r>
+              <a:rPr lang="pt-BR" dirty="0" err="1"/>
+              <a:t>Relevancia</a:t>
+            </a:r>
+            <a:endParaRPr dirty="0"/>
           </a:p>
           <a:p>
             <a:pPr>
@@ -6322,7 +6583,152 @@
               </a:defRPr>
             </a:pPr>
             <a:r>
-              <a:t>Nossa tese precisa medir tom de pele de forma confiável e granular. MST é o padrão moderno aceito pela comunidade de fairness research (publicado em NeurIPS 2023). Substituir a Fitzpatrick pela MST evita 3 problemas conhecidos da escala antiga.</a:t>
+              <a:rPr dirty="0"/>
+              <a:t>Nossa </a:t>
+            </a:r>
+            <a:r>
+              <a:rPr dirty="0" err="1"/>
+              <a:t>tese</a:t>
+            </a:r>
+            <a:r>
+              <a:rPr dirty="0"/>
+              <a:t> </a:t>
+            </a:r>
+            <a:r>
+              <a:rPr dirty="0" err="1"/>
+              <a:t>precisa</a:t>
+            </a:r>
+            <a:r>
+              <a:rPr dirty="0"/>
+              <a:t> </a:t>
+            </a:r>
+            <a:r>
+              <a:rPr dirty="0" err="1"/>
+              <a:t>medir</a:t>
+            </a:r>
+            <a:r>
+              <a:rPr dirty="0"/>
+              <a:t> tom de </a:t>
+            </a:r>
+            <a:r>
+              <a:rPr dirty="0" err="1"/>
+              <a:t>pele</a:t>
+            </a:r>
+            <a:r>
+              <a:rPr dirty="0"/>
+              <a:t> de forma </a:t>
+            </a:r>
+            <a:r>
+              <a:rPr dirty="0" err="1"/>
+              <a:t>confiável</a:t>
+            </a:r>
+            <a:r>
+              <a:rPr dirty="0"/>
+              <a:t> e granular. MST é o </a:t>
+            </a:r>
+            <a:r>
+              <a:rPr dirty="0" err="1"/>
+              <a:t>padrão</a:t>
+            </a:r>
+            <a:r>
+              <a:rPr dirty="0"/>
+              <a:t> </a:t>
+            </a:r>
+            <a:r>
+              <a:rPr dirty="0" err="1"/>
+              <a:t>moderno</a:t>
+            </a:r>
+            <a:r>
+              <a:rPr dirty="0"/>
+              <a:t> </a:t>
+            </a:r>
+            <a:r>
+              <a:rPr dirty="0" err="1"/>
+              <a:t>aceito</a:t>
+            </a:r>
+            <a:r>
+              <a:rPr dirty="0"/>
+              <a:t> pela </a:t>
+            </a:r>
+            <a:r>
+              <a:rPr dirty="0" err="1"/>
+              <a:t>comunidade</a:t>
+            </a:r>
+            <a:r>
+              <a:rPr dirty="0"/>
+              <a:t> de fairness research (</a:t>
+            </a:r>
+            <a:r>
+              <a:rPr dirty="0" err="1"/>
+              <a:t>publicado</a:t>
+            </a:r>
+            <a:r>
+              <a:rPr dirty="0"/>
+              <a:t> </a:t>
+            </a:r>
+            <a:r>
+              <a:rPr dirty="0" err="1"/>
+              <a:t>em</a:t>
+            </a:r>
+            <a:r>
+              <a:rPr dirty="0"/>
+              <a:t> </a:t>
+            </a:r>
+            <a:r>
+              <a:rPr dirty="0" err="1"/>
+              <a:t>NeurIPS</a:t>
+            </a:r>
+            <a:r>
+              <a:rPr dirty="0"/>
+              <a:t> 2023). </a:t>
+            </a:r>
+            <a:r>
+              <a:rPr dirty="0" err="1"/>
+              <a:t>Substituir</a:t>
+            </a:r>
+            <a:r>
+              <a:rPr dirty="0"/>
+              <a:t> a Fitzpatrick pela MST </a:t>
+            </a:r>
+            <a:r>
+              <a:rPr dirty="0" err="1"/>
+              <a:t>evita</a:t>
+            </a:r>
+            <a:r>
+              <a:rPr dirty="0"/>
+              <a:t> 3 </a:t>
+            </a:r>
+            <a:r>
+              <a:rPr dirty="0" err="1"/>
+              <a:t>problemas</a:t>
+            </a:r>
+            <a:r>
+              <a:rPr dirty="0"/>
+              <a:t> </a:t>
+            </a:r>
+            <a:r>
+              <a:rPr dirty="0" err="1"/>
+              <a:t>conhecidos</a:t>
+            </a:r>
+            <a:r>
+              <a:rPr dirty="0"/>
+              <a:t> da </a:t>
+            </a:r>
+            <a:r>
+              <a:rPr dirty="0" err="1"/>
+              <a:t>escala</a:t>
+            </a:r>
+            <a:r>
+              <a:rPr dirty="0"/>
+              <a:t> </a:t>
+            </a:r>
+            <a:r>
+              <a:rPr dirty="0" err="1"/>
+              <a:t>antiga</a:t>
+            </a:r>
+            <a:r>
+              <a:rPr dirty="0"/>
+              <a:t>.</a:t>
             </a:r>
           </a:p>
         </p:txBody>
@@ -6378,14 +6784,6 @@
             <a:r>
               <a:rPr dirty="0" err="1"/>
               <a:t>Exemplo</a:t>
-            </a:r>
-            <a:r>
-              <a:rPr dirty="0"/>
-              <a:t> </a:t>
-            </a:r>
-            <a:r>
-              <a:rPr dirty="0" err="1"/>
-              <a:t>concreto</a:t>
             </a:r>
             <a:endParaRPr dirty="0"/>
           </a:p>
@@ -7232,30 +7630,6 @@
             </a:r>
             <a:r>
               <a:rPr dirty="0"/>
-              <a:t>. É linear </a:t>
-            </a:r>
-            <a:r>
-              <a:rPr dirty="0" err="1"/>
-              <a:t>nas</a:t>
-            </a:r>
-            <a:r>
-              <a:rPr dirty="0"/>
-              <a:t> features e </a:t>
-            </a:r>
-            <a:r>
-              <a:rPr dirty="0" err="1"/>
-              <a:t>não</a:t>
-            </a:r>
-            <a:r>
-              <a:rPr dirty="0"/>
-              <a:t> linear no </a:t>
-            </a:r>
-            <a:r>
-              <a:rPr dirty="0" err="1"/>
-              <a:t>contexto</a:t>
-            </a:r>
-            <a:r>
-              <a:rPr dirty="0"/>
               <a:t>.</a:t>
             </a:r>
           </a:p>
@@ -7568,272 +7942,429 @@
       </p:sp>
       <p:sp>
         <p:nvSpPr>
-          <p:cNvPr id="11" name="Rounded Rectangle 10"/>
-          <p:cNvSpPr/>
+          <p:cNvPr id="13" name="CaixaDeTexto 12">
+            <a:extLst>
+              <a:ext uri="{FF2B5EF4-FFF2-40B4-BE49-F238E27FC236}">
+                <a16:creationId xmlns:a16="http://schemas.microsoft.com/office/drawing/2014/main" id="{C7E15BE2-3796-C153-5EE7-3FD96CECE8FE}"/>
+              </a:ext>
+            </a:extLst>
+          </p:cNvPr>
+          <p:cNvSpPr txBox="1"/>
           <p:nvPr/>
         </p:nvSpPr>
         <p:spPr>
           <a:xfrm>
-            <a:off x="457200" y="5257800"/>
-            <a:ext cx="11430000" cy="1280160"/>
+            <a:off x="4023360" y="5303520"/>
+            <a:ext cx="3495675" cy="1446550"/>
           </a:xfrm>
-          <a:prstGeom prst="roundRect">
+          <a:prstGeom prst="rect">
             <a:avLst/>
           </a:prstGeom>
-          <a:solidFill>
-            <a:srgbClr val="FFFFFF"/>
-          </a:solidFill>
-          <a:ln w="19050">
-            <a:solidFill>
-              <a:srgbClr val="2E7D32"/>
-            </a:solidFill>
-          </a:ln>
+          <a:noFill/>
         </p:spPr>
-        <p:style>
-          <a:lnRef idx="1">
-            <a:schemeClr val="accent1"/>
-          </a:lnRef>
-          <a:fillRef idx="3">
-            <a:schemeClr val="accent1"/>
-          </a:fillRef>
-          <a:effectRef idx="2">
-            <a:schemeClr val="accent1"/>
-          </a:effectRef>
-          <a:fontRef idx="minor">
-            <a:schemeClr val="lt1"/>
-          </a:fontRef>
-        </p:style>
-        <p:txBody>
-          <a:bodyPr wrap="square" lIns="228600" tIns="109728" rIns="228600" rtlCol="0" anchor="ctr"/>
+        <p:txBody>
+          <a:bodyPr wrap="square">
+            <a:spAutoFit/>
+          </a:bodyPr>
           <a:lstStyle/>
           <a:p>
-            <a:pPr algn="ctr">
-              <a:defRPr sz="1300" b="1">
-                <a:solidFill>
-                  <a:srgbClr val="2E7D32"/>
-                </a:solidFill>
-              </a:defRPr>
-            </a:pPr>
-            <a:r>
-              <a:rPr dirty="0"/>
-              <a:t>Por </a:t>
-            </a:r>
-            <a:r>
-              <a:rPr dirty="0" err="1"/>
-              <a:t>que</a:t>
-            </a:r>
-            <a:r>
-              <a:rPr dirty="0"/>
+            <a:pPr algn="l">
+              <a:buNone/>
+            </a:pPr>
+            <a:r>
+              <a:rPr lang="pt-BR" sz="800" b="0" i="0" dirty="0">
+                <a:solidFill>
+                  <a:srgbClr val="BBBEBF"/>
+                </a:solidFill>
+                <a:effectLst/>
+                <a:latin typeface="Consolas" panose="020B0609020204030204" pitchFamily="49" charset="0"/>
+              </a:rPr>
+              <a:t>Imagem → CNN (</a:t>
+            </a:r>
+            <a:r>
+              <a:rPr lang="pt-BR" sz="800" b="0" i="0" dirty="0" err="1">
+                <a:solidFill>
+                  <a:srgbClr val="BBBEBF"/>
+                </a:solidFill>
+                <a:effectLst/>
+                <a:latin typeface="Consolas" panose="020B0609020204030204" pitchFamily="49" charset="0"/>
+              </a:rPr>
+              <a:t>ResNet</a:t>
+            </a:r>
+            <a:r>
+              <a:rPr lang="pt-BR" sz="800" b="0" i="0" dirty="0">
+                <a:solidFill>
+                  <a:srgbClr val="BBBEBF"/>
+                </a:solidFill>
+                <a:effectLst/>
+                <a:latin typeface="Consolas" panose="020B0609020204030204" pitchFamily="49" charset="0"/>
+              </a:rPr>
+              <a:t>/</a:t>
+            </a:r>
+            <a:r>
+              <a:rPr lang="pt-BR" sz="800" b="0" i="0" dirty="0" err="1">
+                <a:solidFill>
+                  <a:srgbClr val="BBBEBF"/>
+                </a:solidFill>
+                <a:effectLst/>
+                <a:latin typeface="Consolas" panose="020B0609020204030204" pitchFamily="49" charset="0"/>
+              </a:rPr>
+              <a:t>ConvNeXt</a:t>
+            </a:r>
+            <a:r>
+              <a:rPr lang="pt-BR" sz="800" b="0" i="0" dirty="0">
+                <a:solidFill>
+                  <a:srgbClr val="BBBEBF"/>
+                </a:solidFill>
+                <a:effectLst/>
+                <a:latin typeface="Consolas" panose="020B0609020204030204" pitchFamily="49" charset="0"/>
+              </a:rPr>
+              <a:t>)</a:t>
+            </a:r>
+          </a:p>
+          <a:p>
+            <a:pPr algn="l">
+              <a:buNone/>
+            </a:pPr>
+            <a:r>
+              <a:rPr lang="pt-BR" sz="800" b="0" i="0" dirty="0">
+                <a:solidFill>
+                  <a:srgbClr val="BBBEBF"/>
+                </a:solidFill>
+                <a:effectLst/>
+                <a:latin typeface="Consolas" panose="020B0609020204030204" pitchFamily="49" charset="0"/>
+              </a:rPr>
+              <a:t>                    ↓</a:t>
+            </a:r>
+          </a:p>
+          <a:p>
+            <a:pPr algn="l">
+              <a:buNone/>
+            </a:pPr>
+            <a:r>
+              <a:rPr lang="pt-BR" sz="800" b="0" i="0" dirty="0">
+                <a:solidFill>
+                  <a:srgbClr val="BBBEBF"/>
+                </a:solidFill>
+                <a:effectLst/>
+                <a:latin typeface="Consolas" panose="020B0609020204030204" pitchFamily="49" charset="0"/>
+              </a:rPr>
+              <a:t>   MST </a:t>
+            </a:r>
+            <a:r>
+              <a:rPr lang="pt-BR" sz="800" b="0" i="0" dirty="0" err="1">
+                <a:solidFill>
+                  <a:srgbClr val="BBBEBF"/>
+                </a:solidFill>
+                <a:effectLst/>
+                <a:latin typeface="Consolas" panose="020B0609020204030204" pitchFamily="49" charset="0"/>
+              </a:rPr>
+              <a:t>classifier</a:t>
+            </a:r>
+            <a:r>
+              <a:rPr lang="pt-BR" sz="800" b="0" i="0" dirty="0">
+                <a:solidFill>
+                  <a:srgbClr val="BBBEBF"/>
+                </a:solidFill>
+                <a:effectLst/>
+                <a:latin typeface="Consolas" panose="020B0609020204030204" pitchFamily="49" charset="0"/>
+              </a:rPr>
+              <a:t> ──▶ vetor z (10 </a:t>
+            </a:r>
+            <a:r>
+              <a:rPr lang="pt-BR" sz="800" b="0" i="0" dirty="0" err="1">
+                <a:solidFill>
+                  <a:srgbClr val="BBBEBF"/>
+                </a:solidFill>
+                <a:effectLst/>
+                <a:latin typeface="Consolas" panose="020B0609020204030204" pitchFamily="49" charset="0"/>
+              </a:rPr>
+              <a:t>logits</a:t>
+            </a:r>
+            <a:r>
+              <a:rPr lang="pt-BR" sz="800" b="0" i="0" dirty="0">
+                <a:solidFill>
+                  <a:srgbClr val="BBBEBF"/>
+                </a:solidFill>
+                <a:effectLst/>
+                <a:latin typeface="Consolas" panose="020B0609020204030204" pitchFamily="49" charset="0"/>
+              </a:rPr>
+              <a:t>)</a:t>
+            </a:r>
+          </a:p>
+          <a:p>
+            <a:pPr algn="l">
+              <a:buNone/>
+            </a:pPr>
+            <a:r>
+              <a:rPr lang="pt-BR" sz="800" b="0" i="0" dirty="0">
+                <a:solidFill>
+                  <a:srgbClr val="BBBEBF"/>
+                </a:solidFill>
+                <a:effectLst/>
+                <a:latin typeface="Consolas" panose="020B0609020204030204" pitchFamily="49" charset="0"/>
+              </a:rPr>
+              <a:t>                    ↓</a:t>
+            </a:r>
+          </a:p>
+          <a:p>
+            <a:pPr algn="l">
+              <a:buNone/>
+            </a:pPr>
+            <a:r>
+              <a:rPr lang="pt-BR" sz="800" b="0" i="0" dirty="0">
+                <a:solidFill>
+                  <a:srgbClr val="BBBEBF"/>
+                </a:solidFill>
+                <a:effectLst/>
+                <a:latin typeface="Consolas" panose="020B0609020204030204" pitchFamily="49" charset="0"/>
+              </a:rPr>
+              <a:t>                </a:t>
+            </a:r>
+            <a:r>
+              <a:rPr lang="pt-BR" sz="800" b="0" i="0" dirty="0" err="1">
+                <a:solidFill>
+                  <a:srgbClr val="BBBEBF"/>
+                </a:solidFill>
+                <a:effectLst/>
+                <a:latin typeface="Consolas" panose="020B0609020204030204" pitchFamily="49" charset="0"/>
+              </a:rPr>
+              <a:t>FiLM</a:t>
+            </a:r>
+            <a:r>
+              <a:rPr lang="pt-BR" sz="800" b="0" i="0" dirty="0">
+                <a:solidFill>
+                  <a:srgbClr val="BBBEBF"/>
+                </a:solidFill>
+                <a:effectLst/>
+                <a:latin typeface="Consolas" panose="020B0609020204030204" pitchFamily="49" charset="0"/>
+              </a:rPr>
               <a:t> </a:t>
             </a:r>
             <a:r>
-              <a:rPr dirty="0" err="1"/>
-              <a:t>importa</a:t>
-            </a:r>
-            <a:r>
-              <a:rPr dirty="0"/>
-              <a:t> para a </a:t>
-            </a:r>
-            <a:r>
-              <a:rPr dirty="0" err="1"/>
-              <a:t>tese</a:t>
-            </a:r>
-            <a:endParaRPr lang="pt-BR" dirty="0"/>
-          </a:p>
-          <a:p>
-            <a:pPr algn="ctr">
-              <a:defRPr sz="1300" b="1">
-                <a:solidFill>
-                  <a:srgbClr val="2E7D32"/>
-                </a:solidFill>
-              </a:defRPr>
-            </a:pPr>
-            <a:endParaRPr dirty="0"/>
-          </a:p>
-          <a:p>
-            <a:pPr>
-              <a:defRPr sz="1200">
-                <a:solidFill>
-                  <a:srgbClr val="3D424E"/>
-                </a:solidFill>
-              </a:defRPr>
-            </a:pPr>
-            <a:r>
-              <a:rPr dirty="0" err="1"/>
-              <a:t>FiLM</a:t>
-            </a:r>
-            <a:r>
-              <a:rPr dirty="0"/>
+              <a:rPr lang="pt-BR" sz="800" b="0" i="0" dirty="0" err="1">
+                <a:solidFill>
+                  <a:srgbClr val="BBBEBF"/>
+                </a:solidFill>
+                <a:effectLst/>
+                <a:latin typeface="Consolas" panose="020B0609020204030204" pitchFamily="49" charset="0"/>
+              </a:rPr>
+              <a:t>layer</a:t>
+            </a:r>
+            <a:r>
+              <a:rPr lang="pt-BR" sz="800" b="0" i="0" dirty="0">
+                <a:solidFill>
+                  <a:srgbClr val="BBBEBF"/>
+                </a:solidFill>
+                <a:effectLst/>
+                <a:latin typeface="Consolas" panose="020B0609020204030204" pitchFamily="49" charset="0"/>
+              </a:rPr>
+              <a:t> ── γ, β</a:t>
+            </a:r>
+          </a:p>
+          <a:p>
+            <a:pPr algn="l">
+              <a:buNone/>
+            </a:pPr>
+            <a:r>
+              <a:rPr lang="pt-BR" sz="800" b="0" i="0" dirty="0">
+                <a:solidFill>
+                  <a:srgbClr val="BBBEBF"/>
+                </a:solidFill>
+                <a:effectLst/>
+                <a:latin typeface="Consolas" panose="020B0609020204030204" pitchFamily="49" charset="0"/>
+              </a:rPr>
+              <a:t>                    ↓</a:t>
+            </a:r>
+          </a:p>
+          <a:p>
+            <a:pPr algn="l">
+              <a:buNone/>
+            </a:pPr>
+            <a:r>
+              <a:rPr lang="pt-BR" sz="800" b="0" i="0" dirty="0">
+                <a:solidFill>
+                  <a:srgbClr val="BBBEBF"/>
+                </a:solidFill>
+                <a:effectLst/>
+                <a:latin typeface="Consolas" panose="020B0609020204030204" pitchFamily="49" charset="0"/>
+              </a:rPr>
+              <a:t>              feature </a:t>
+            </a:r>
+            <a:r>
+              <a:rPr lang="pt-BR" sz="800" b="0" i="0" dirty="0" err="1">
+                <a:solidFill>
+                  <a:srgbClr val="BBBEBF"/>
+                </a:solidFill>
+                <a:effectLst/>
+                <a:latin typeface="Consolas" panose="020B0609020204030204" pitchFamily="49" charset="0"/>
+              </a:rPr>
+              <a:t>map</a:t>
+            </a:r>
+            <a:r>
+              <a:rPr lang="pt-BR" sz="800" b="0" i="0" dirty="0">
+                <a:solidFill>
+                  <a:srgbClr val="BBBEBF"/>
+                </a:solidFill>
+                <a:effectLst/>
+                <a:latin typeface="Consolas" panose="020B0609020204030204" pitchFamily="49" charset="0"/>
+              </a:rPr>
+              <a:t> modulado</a:t>
+            </a:r>
+          </a:p>
+          <a:p>
+            <a:pPr algn="l">
+              <a:buNone/>
+            </a:pPr>
+            <a:r>
+              <a:rPr lang="pt-BR" sz="800" b="0" i="0" dirty="0">
+                <a:solidFill>
+                  <a:srgbClr val="BBBEBF"/>
+                </a:solidFill>
+                <a:effectLst/>
+                <a:latin typeface="Consolas" panose="020B0609020204030204" pitchFamily="49" charset="0"/>
+              </a:rPr>
+              <a:t>                    ↓</a:t>
+            </a:r>
+          </a:p>
+          <a:p>
+            <a:pPr algn="l">
+              <a:buNone/>
+            </a:pPr>
+            <a:r>
+              <a:rPr lang="pt-BR" sz="800" b="0" i="0" dirty="0">
+                <a:solidFill>
+                  <a:srgbClr val="BBBEBF"/>
+                </a:solidFill>
+                <a:effectLst/>
+                <a:latin typeface="Consolas" panose="020B0609020204030204" pitchFamily="49" charset="0"/>
+              </a:rPr>
+              <a:t>              </a:t>
+            </a:r>
+            <a:r>
+              <a:rPr lang="pt-BR" sz="800" b="0" i="0" dirty="0" err="1">
+                <a:solidFill>
+                  <a:srgbClr val="BBBEBF"/>
+                </a:solidFill>
+                <a:effectLst/>
+                <a:latin typeface="Consolas" panose="020B0609020204030204" pitchFamily="49" charset="0"/>
+              </a:rPr>
+              <a:t>race</a:t>
+            </a:r>
+            <a:r>
+              <a:rPr lang="pt-BR" sz="800" b="0" i="0" dirty="0">
+                <a:solidFill>
+                  <a:srgbClr val="BBBEBF"/>
+                </a:solidFill>
+                <a:effectLst/>
+                <a:latin typeface="Consolas" panose="020B0609020204030204" pitchFamily="49" charset="0"/>
+              </a:rPr>
               <a:t> </a:t>
             </a:r>
             <a:r>
-              <a:rPr dirty="0" err="1"/>
-              <a:t>transforma</a:t>
-            </a:r>
-            <a:r>
-              <a:rPr dirty="0"/>
-              <a:t> a </a:t>
-            </a:r>
-            <a:r>
-              <a:rPr dirty="0" err="1"/>
-              <a:t>ideia</a:t>
-            </a:r>
-            <a:r>
-              <a:rPr dirty="0"/>
-              <a:t> 'usar tom de </a:t>
-            </a:r>
-            <a:r>
-              <a:rPr dirty="0" err="1"/>
-              <a:t>pele</a:t>
-            </a:r>
-            <a:r>
-              <a:rPr dirty="0"/>
+              <a:rPr lang="pt-BR" sz="800" b="0" i="0" dirty="0" err="1">
+                <a:solidFill>
+                  <a:srgbClr val="BBBEBF"/>
+                </a:solidFill>
+                <a:effectLst/>
+                <a:latin typeface="Consolas" panose="020B0609020204030204" pitchFamily="49" charset="0"/>
+              </a:rPr>
+              <a:t>classifier</a:t>
+            </a:r>
+            <a:r>
+              <a:rPr lang="pt-BR" sz="800" b="0" i="0" dirty="0">
+                <a:solidFill>
+                  <a:srgbClr val="BBBEBF"/>
+                </a:solidFill>
+                <a:effectLst/>
+                <a:latin typeface="Consolas" panose="020B0609020204030204" pitchFamily="49" charset="0"/>
+              </a:rPr>
               <a:t> </a:t>
             </a:r>
             <a:r>
-              <a:rPr dirty="0" err="1"/>
-              <a:t>como</a:t>
-            </a:r>
-            <a:r>
-              <a:rPr dirty="0"/>
+              <a:rPr lang="pt-BR" sz="800" b="0" i="0" dirty="0" err="1">
+                <a:solidFill>
+                  <a:srgbClr val="BBBEBF"/>
+                </a:solidFill>
+                <a:effectLst/>
+                <a:latin typeface="Consolas" panose="020B0609020204030204" pitchFamily="49" charset="0"/>
+              </a:rPr>
+              <a:t>head</a:t>
+            </a:r>
+            <a:endParaRPr lang="pt-BR" sz="800" b="0" i="0" dirty="0">
+              <a:solidFill>
+                <a:srgbClr val="BBBEBF"/>
+              </a:solidFill>
+              <a:effectLst/>
+              <a:latin typeface="Consolas" panose="020B0609020204030204" pitchFamily="49" charset="0"/>
+            </a:endParaRPr>
+          </a:p>
+          <a:p>
+            <a:pPr algn="l">
+              <a:buNone/>
+            </a:pPr>
+            <a:r>
+              <a:rPr lang="pt-BR" sz="800" b="0" i="0" dirty="0">
+                <a:solidFill>
+                  <a:srgbClr val="BBBEBF"/>
+                </a:solidFill>
+                <a:effectLst/>
+                <a:latin typeface="Consolas" panose="020B0609020204030204" pitchFamily="49" charset="0"/>
+              </a:rPr>
+              <a:t>                    ↓</a:t>
+            </a:r>
+          </a:p>
+          <a:p>
+            <a:pPr algn="l">
+              <a:buNone/>
+            </a:pPr>
+            <a:r>
+              <a:rPr lang="pt-BR" sz="800" b="0" i="0" dirty="0">
+                <a:solidFill>
+                  <a:srgbClr val="BBBEBF"/>
+                </a:solidFill>
+                <a:effectLst/>
+                <a:latin typeface="Consolas" panose="020B0609020204030204" pitchFamily="49" charset="0"/>
+              </a:rPr>
+              <a:t>                </a:t>
+            </a:r>
+            <a:r>
+              <a:rPr lang="pt-BR" sz="800" b="0" i="0" dirty="0" err="1">
+                <a:solidFill>
+                  <a:srgbClr val="BBBEBF"/>
+                </a:solidFill>
+                <a:effectLst/>
+                <a:latin typeface="Consolas" panose="020B0609020204030204" pitchFamily="49" charset="0"/>
+              </a:rPr>
+              <a:t>race</a:t>
+            </a:r>
+            <a:r>
+              <a:rPr lang="pt-BR" sz="800" b="0" i="0" dirty="0">
+                <a:solidFill>
+                  <a:srgbClr val="BBBEBF"/>
+                </a:solidFill>
+                <a:effectLst/>
+                <a:latin typeface="Consolas" panose="020B0609020204030204" pitchFamily="49" charset="0"/>
+              </a:rPr>
               <a:t> </a:t>
             </a:r>
             <a:r>
-              <a:rPr dirty="0" err="1"/>
-              <a:t>contexto</a:t>
-            </a:r>
-            <a:r>
-              <a:rPr dirty="0"/>
-              <a:t>' </a:t>
-            </a:r>
-            <a:r>
-              <a:rPr dirty="0" err="1"/>
-              <a:t>em</a:t>
-            </a:r>
-            <a:r>
-              <a:rPr dirty="0"/>
-              <a:t> </a:t>
-            </a:r>
-            <a:r>
-              <a:rPr dirty="0" err="1"/>
-              <a:t>mecanismo</a:t>
-            </a:r>
-            <a:r>
-              <a:rPr dirty="0"/>
-              <a:t> formal, </a:t>
-            </a:r>
-            <a:r>
-              <a:rPr dirty="0" err="1"/>
-              <a:t>reproduzível</a:t>
-            </a:r>
-            <a:r>
-              <a:rPr dirty="0"/>
-              <a:t> e </a:t>
-            </a:r>
-            <a:r>
-              <a:rPr dirty="0" err="1"/>
-              <a:t>auditável</a:t>
-            </a:r>
-            <a:r>
-              <a:rPr dirty="0"/>
-              <a:t>. O </a:t>
-            </a:r>
-            <a:r>
-              <a:rPr dirty="0" err="1"/>
-              <a:t>ganho</a:t>
-            </a:r>
-            <a:r>
-              <a:rPr dirty="0"/>
-              <a:t> marginal </a:t>
-            </a:r>
-            <a:r>
-              <a:rPr dirty="0" err="1"/>
-              <a:t>sobre</a:t>
-            </a:r>
-            <a:r>
-              <a:rPr dirty="0"/>
-              <a:t> baseline puro é a </a:t>
-            </a:r>
-            <a:r>
-              <a:rPr dirty="0" err="1"/>
-              <a:t>evidência</a:t>
-            </a:r>
-            <a:r>
-              <a:rPr dirty="0"/>
-              <a:t> </a:t>
-            </a:r>
-            <a:r>
-              <a:rPr dirty="0" err="1"/>
-              <a:t>direta</a:t>
-            </a:r>
-            <a:r>
-              <a:rPr dirty="0"/>
-              <a:t> de H1. </a:t>
-            </a:r>
-            <a:r>
-              <a:rPr dirty="0" err="1"/>
-              <a:t>Custo</a:t>
-            </a:r>
-            <a:r>
-              <a:rPr dirty="0"/>
-              <a:t> de </a:t>
-            </a:r>
-            <a:r>
-              <a:rPr dirty="0" err="1"/>
-              <a:t>parâmetros</a:t>
-            </a:r>
-            <a:r>
-              <a:rPr dirty="0"/>
-              <a:t> </a:t>
-            </a:r>
-            <a:r>
-              <a:rPr dirty="0" err="1"/>
-              <a:t>adicional</a:t>
-            </a:r>
-            <a:r>
-              <a:rPr dirty="0"/>
-              <a:t> é </a:t>
-            </a:r>
-            <a:r>
-              <a:rPr dirty="0" err="1"/>
-              <a:t>mínimo</a:t>
-            </a:r>
-            <a:r>
-              <a:rPr dirty="0"/>
-              <a:t> (</a:t>
-            </a:r>
-            <a:r>
-              <a:rPr dirty="0" err="1"/>
-              <a:t>apenas</a:t>
-            </a:r>
-            <a:r>
-              <a:rPr dirty="0"/>
-              <a:t> duas MLPs </a:t>
-            </a:r>
-            <a:r>
-              <a:rPr dirty="0" err="1"/>
-              <a:t>pequenas</a:t>
-            </a:r>
-            <a:r>
-              <a:rPr dirty="0"/>
-              <a:t> </a:t>
-            </a:r>
-            <a:r>
-              <a:rPr dirty="0" err="1"/>
-              <a:t>por</a:t>
-            </a:r>
-            <a:r>
-              <a:rPr dirty="0"/>
-              <a:t> </a:t>
-            </a:r>
-            <a:r>
-              <a:rPr dirty="0" err="1"/>
-              <a:t>bloco</a:t>
-            </a:r>
-            <a:r>
-              <a:rPr dirty="0"/>
-              <a:t>).</a:t>
-            </a:r>
+              <a:rPr lang="pt-BR" sz="800" b="0" i="0" dirty="0" err="1">
+                <a:solidFill>
+                  <a:srgbClr val="BBBEBF"/>
+                </a:solidFill>
+                <a:effectLst/>
+                <a:latin typeface="Consolas" panose="020B0609020204030204" pitchFamily="49" charset="0"/>
+              </a:rPr>
+              <a:t>prediction</a:t>
+            </a:r>
+            <a:endParaRPr lang="pt-BR" sz="800" b="0" i="0" dirty="0">
+              <a:solidFill>
+                <a:srgbClr val="BBBEBF"/>
+              </a:solidFill>
+              <a:effectLst/>
+              <a:latin typeface="Courier New" panose="02070309020205020404" pitchFamily="49" charset="0"/>
+            </a:endParaRPr>
           </a:p>
         </p:txBody>
       </p:sp>
@@ -9033,28 +9564,8 @@
               </a:defRPr>
             </a:pPr>
             <a:r>
-              <a:rPr dirty="0"/>
-              <a:t>Por </a:t>
-            </a:r>
-            <a:r>
-              <a:rPr dirty="0" err="1"/>
-              <a:t>que</a:t>
-            </a:r>
-            <a:r>
-              <a:rPr dirty="0"/>
-              <a:t> </a:t>
-            </a:r>
-            <a:r>
-              <a:rPr dirty="0" err="1"/>
-              <a:t>importa</a:t>
-            </a:r>
-            <a:r>
-              <a:rPr dirty="0"/>
-              <a:t> para a </a:t>
-            </a:r>
-            <a:r>
-              <a:rPr dirty="0" err="1"/>
-              <a:t>tese</a:t>
+              <a:rPr lang="pt-BR" dirty="0" err="1"/>
+              <a:t>Relevancia</a:t>
             </a:r>
             <a:endParaRPr lang="pt-BR" dirty="0"/>
           </a:p>
@@ -9276,7 +9787,7 @@
         <p:spPr>
           <a:xfrm>
             <a:off x="548640" y="1371600"/>
-            <a:ext cx="11247120" cy="4937760"/>
+            <a:ext cx="11247120" cy="4637167"/>
           </a:xfrm>
           <a:prstGeom prst="rect">
             <a:avLst/>
@@ -9304,12 +9815,20 @@
               <a:t>Etapa 1 — </a:t>
             </a:r>
             <a:r>
-              <a:rPr dirty="0" err="1"/>
-              <a:t>Treinar</a:t>
-            </a:r>
-            <a:r>
-              <a:rPr dirty="0"/>
-              <a:t> um </a:t>
+              <a:rPr lang="pt-BR" dirty="0"/>
+              <a:t>Preparar</a:t>
+            </a:r>
+            <a:r>
+              <a:rPr dirty="0"/>
+              <a:t> </a:t>
+            </a:r>
+            <a:r>
+              <a:rPr lang="pt-BR" dirty="0"/>
+              <a:t>o</a:t>
+            </a:r>
+            <a:r>
+              <a:rPr dirty="0"/>
+              <a:t> </a:t>
             </a:r>
             <a:r>
               <a:rPr dirty="0" err="1"/>
@@ -11796,103 +12315,6 @@
           </a:graphicData>
         </a:graphic>
       </p:graphicFrame>
-      <p:sp>
-        <p:nvSpPr>
-          <p:cNvPr id="5" name="TextBox 4"/>
-          <p:cNvSpPr txBox="1"/>
-          <p:nvPr/>
-        </p:nvSpPr>
-        <p:spPr>
-          <a:xfrm>
-            <a:off x="457200" y="6400800"/>
-            <a:ext cx="11430000" cy="365760"/>
-          </a:xfrm>
-          <a:prstGeom prst="rect">
-            <a:avLst/>
-          </a:prstGeom>
-          <a:noFill/>
-        </p:spPr>
-        <p:txBody>
-          <a:bodyPr wrap="none">
-            <a:spAutoFit/>
-          </a:bodyPr>
-          <a:lstStyle/>
-          <a:p>
-            <a:pPr>
-              <a:defRPr sz="1500" i="1">
-                <a:solidFill>
-                  <a:srgbClr val="707682"/>
-                </a:solidFill>
-              </a:defRPr>
-            </a:pPr>
-            <a:r>
-              <a:rPr dirty="0"/>
-              <a:t>H5 </a:t>
-            </a:r>
-            <a:r>
-              <a:rPr dirty="0" err="1"/>
-              <a:t>em</a:t>
-            </a:r>
-            <a:r>
-              <a:rPr dirty="0"/>
-              <a:t> </a:t>
-            </a:r>
-            <a:r>
-              <a:rPr dirty="0" err="1"/>
-              <a:t>revisão</a:t>
-            </a:r>
-            <a:r>
-              <a:rPr dirty="0"/>
-              <a:t> </a:t>
-            </a:r>
-            <a:r>
-              <a:rPr dirty="0" err="1"/>
-              <a:t>após</a:t>
-            </a:r>
-            <a:r>
-              <a:rPr dirty="0"/>
-              <a:t> Pangelinan 2023 (</a:t>
-            </a:r>
-            <a:r>
-              <a:rPr dirty="0" err="1"/>
-              <a:t>Rodada</a:t>
-            </a:r>
-            <a:r>
-              <a:rPr dirty="0"/>
-              <a:t> 6): pixel info </a:t>
-            </a:r>
-            <a:r>
-              <a:rPr dirty="0" err="1"/>
-              <a:t>pode</a:t>
-            </a:r>
-            <a:r>
-              <a:rPr dirty="0"/>
-              <a:t> ser confounder — </a:t>
-            </a:r>
-            <a:r>
-              <a:rPr dirty="0" err="1"/>
-              <a:t>discussão</a:t>
-            </a:r>
-            <a:r>
-              <a:rPr dirty="0"/>
-              <a:t> </a:t>
-            </a:r>
-            <a:r>
-              <a:rPr dirty="0" err="1"/>
-              <a:t>na</a:t>
-            </a:r>
-            <a:r>
-              <a:rPr dirty="0"/>
-              <a:t> </a:t>
-            </a:r>
-            <a:r>
-              <a:rPr dirty="0" err="1"/>
-              <a:t>pauta</a:t>
-            </a:r>
-            <a:endParaRPr dirty="0"/>
-          </a:p>
-        </p:txBody>
-      </p:sp>
     </p:spTree>
   </p:cSld>
   <p:clrMapOvr>
@@ -11927,7 +12349,7 @@
         <p:spPr>
           <a:xfrm>
             <a:off x="457200" y="365760"/>
-            <a:ext cx="11430000" cy="822960"/>
+            <a:ext cx="11430000" cy="553998"/>
           </a:xfrm>
           <a:prstGeom prst="rect">
             <a:avLst/>
@@ -11948,8 +12370,10 @@
               </a:defRPr>
             </a:pPr>
             <a:r>
-              <a:t>Principais alinhamentos e decisões</a:t>
-            </a:r>
+              <a:rPr lang="pt-BR" dirty="0"/>
+              <a:t>Agenda</a:t>
+            </a:r>
+            <a:endParaRPr dirty="0"/>
           </a:p>
         </p:txBody>
       </p:sp>
@@ -18514,6 +18938,959 @@
 </p:sld>
 </file>
 
+<file path=ppt/slides/slide33.xml><?xml version="1.0" encoding="utf-8"?>
+<p:sld xmlns:a="http://schemas.openxmlformats.org/drawingml/2006/main" xmlns:r="http://schemas.openxmlformats.org/officeDocument/2006/relationships" xmlns:p="http://schemas.openxmlformats.org/presentationml/2006/main" show="0">
+  <p:cSld>
+    <p:spTree>
+      <p:nvGrpSpPr>
+        <p:cNvPr id="1" name="">
+          <a:extLst>
+            <a:ext uri="{FF2B5EF4-FFF2-40B4-BE49-F238E27FC236}">
+              <a16:creationId xmlns:a16="http://schemas.microsoft.com/office/drawing/2014/main" id="{38FBB4EF-F467-0C00-AB8C-8C5D5A854D8C}"/>
+            </a:ext>
+          </a:extLst>
+        </p:cNvPr>
+        <p:cNvGrpSpPr/>
+        <p:nvPr/>
+      </p:nvGrpSpPr>
+      <p:grpSpPr>
+        <a:xfrm>
+          <a:off x="0" y="0"/>
+          <a:ext cx="0" cy="0"/>
+          <a:chOff x="0" y="0"/>
+          <a:chExt cx="0" cy="0"/>
+        </a:xfrm>
+      </p:grpSpPr>
+      <p:sp>
+        <p:nvSpPr>
+          <p:cNvPr id="2" name="TextBox 1">
+            <a:extLst>
+              <a:ext uri="{FF2B5EF4-FFF2-40B4-BE49-F238E27FC236}">
+                <a16:creationId xmlns:a16="http://schemas.microsoft.com/office/drawing/2014/main" id="{E9D72453-877B-E3BB-6EB7-FC08227970B2}"/>
+              </a:ext>
+            </a:extLst>
+          </p:cNvPr>
+          <p:cNvSpPr txBox="1"/>
+          <p:nvPr/>
+        </p:nvSpPr>
+        <p:spPr>
+          <a:xfrm>
+            <a:off x="365760" y="182880"/>
+            <a:ext cx="3736985" cy="369332"/>
+          </a:xfrm>
+          <a:prstGeom prst="rect">
+            <a:avLst/>
+          </a:prstGeom>
+          <a:noFill/>
+        </p:spPr>
+        <p:txBody>
+          <a:bodyPr wrap="none">
+            <a:spAutoFit/>
+          </a:bodyPr>
+          <a:lstStyle/>
+          <a:p>
+            <a:pPr>
+              <a:defRPr sz="1800" b="1">
+                <a:solidFill>
+                  <a:srgbClr val="1F2A4E"/>
+                </a:solidFill>
+              </a:defRPr>
+            </a:pPr>
+            <a:r>
+              <a:rPr lang="pt-BR" dirty="0"/>
+              <a:t>29 Artigos organizados nas 7 Tracking</a:t>
+            </a:r>
+            <a:endParaRPr dirty="0"/>
+          </a:p>
+        </p:txBody>
+      </p:sp>
+      <p:graphicFrame>
+        <p:nvGraphicFramePr>
+          <p:cNvPr id="12" name="Tabela 11">
+            <a:extLst>
+              <a:ext uri="{FF2B5EF4-FFF2-40B4-BE49-F238E27FC236}">
+                <a16:creationId xmlns:a16="http://schemas.microsoft.com/office/drawing/2014/main" id="{09F86733-569E-7179-7640-773B1795E310}"/>
+              </a:ext>
+            </a:extLst>
+          </p:cNvPr>
+          <p:cNvGraphicFramePr>
+            <a:graphicFrameLocks noGrp="1"/>
+          </p:cNvGraphicFramePr>
+          <p:nvPr>
+            <p:extLst>
+              <p:ext uri="{D42A27DB-BD31-4B8C-83A1-F6EECF244321}">
+                <p14:modId xmlns:p14="http://schemas.microsoft.com/office/powerpoint/2010/main" val="1681861248"/>
+              </p:ext>
+            </p:extLst>
+          </p:nvPr>
+        </p:nvGraphicFramePr>
+        <p:xfrm>
+          <a:off x="495300" y="1600201"/>
+          <a:ext cx="10953750" cy="4525960"/>
+        </p:xfrm>
+        <a:graphic>
+          <a:graphicData uri="http://schemas.openxmlformats.org/drawingml/2006/table">
+            <a:tbl>
+              <a:tblPr>
+                <a:tableStyleId>{BC89EF96-8CEA-46FF-86C4-4CE0E7609802}</a:tableStyleId>
+              </a:tblPr>
+              <a:tblGrid>
+                <a:gridCol w="5476875">
+                  <a:extLst>
+                    <a:ext uri="{9D8B030D-6E8A-4147-A177-3AD203B41FA5}">
+                      <a16:colId xmlns:a16="http://schemas.microsoft.com/office/drawing/2014/main" val="3571605357"/>
+                    </a:ext>
+                  </a:extLst>
+                </a:gridCol>
+                <a:gridCol w="5476875">
+                  <a:extLst>
+                    <a:ext uri="{9D8B030D-6E8A-4147-A177-3AD203B41FA5}">
+                      <a16:colId xmlns:a16="http://schemas.microsoft.com/office/drawing/2014/main" val="3873332870"/>
+                    </a:ext>
+                  </a:extLst>
+                </a:gridCol>
+              </a:tblGrid>
+              <a:tr h="238421">
+                <a:tc>
+                  <a:txBody>
+                    <a:bodyPr/>
+                    <a:lstStyle/>
+                    <a:p>
+                      <a:pPr>
+                        <a:buNone/>
+                      </a:pPr>
+                      <a:r>
+                        <a:rPr lang="pt-BR" sz="1400" dirty="0">
+                          <a:effectLst/>
+                        </a:rPr>
+                        <a:t>Track</a:t>
+                      </a:r>
+                    </a:p>
+                  </a:txBody>
+                  <a:tcPr marL="10103" marR="10103" marT="10103" marB="10103" anchor="ctr"/>
+                </a:tc>
+                <a:tc>
+                  <a:txBody>
+                    <a:bodyPr/>
+                    <a:lstStyle/>
+                    <a:p>
+                      <a:pPr>
+                        <a:buNone/>
+                      </a:pPr>
+                      <a:r>
+                        <a:rPr lang="pt-BR" sz="1400">
+                          <a:effectLst/>
+                        </a:rPr>
+                        <a:t>Papers (links diretos)</a:t>
+                      </a:r>
+                    </a:p>
+                  </a:txBody>
+                  <a:tcPr marL="10103" marR="10103" marT="10103" marB="10103" anchor="ctr"/>
+                </a:tc>
+                <a:extLst>
+                  <a:ext uri="{0D108BD9-81ED-4DB2-BD59-A6C34878D82A}">
+                    <a16:rowId xmlns:a16="http://schemas.microsoft.com/office/drawing/2014/main" val="1449477240"/>
+                  </a:ext>
+                </a:extLst>
+              </a:tr>
+              <a:tr h="456637">
+                <a:tc>
+                  <a:txBody>
+                    <a:bodyPr/>
+                    <a:lstStyle/>
+                    <a:p>
+                      <a:pPr>
+                        <a:buNone/>
+                      </a:pPr>
+                      <a:r>
+                        <a:rPr lang="pt-BR" sz="1400" b="1">
+                          <a:effectLst/>
+                        </a:rPr>
+                        <a:t>A — Race classification</a:t>
+                      </a:r>
+                      <a:endParaRPr lang="pt-BR" sz="1400">
+                        <a:effectLst/>
+                      </a:endParaRPr>
+                    </a:p>
+                  </a:txBody>
+                  <a:tcPr marL="10103" marR="10103" marT="10103" marB="10103" anchor="ctr"/>
+                </a:tc>
+                <a:tc>
+                  <a:txBody>
+                    <a:bodyPr/>
+                    <a:lstStyle/>
+                    <a:p>
+                      <a:pPr>
+                        <a:buNone/>
+                      </a:pPr>
+                      <a:r>
+                        <a:rPr lang="pt-BR" sz="1400">
+                          <a:solidFill>
+                            <a:srgbClr val="48A0C7"/>
+                          </a:solidFill>
+                          <a:effectLst/>
+                          <a:hlinkClick r:id="rId2"/>
+                        </a:rPr>
+                        <a:t>Karkkainen 2021 (FairFace)</a:t>
+                      </a:r>
+                      <a:r>
+                        <a:rPr lang="pt-BR" sz="1400">
+                          <a:effectLst/>
+                        </a:rPr>
+                        <a:t> · </a:t>
+                      </a:r>
+                      <a:r>
+                        <a:rPr lang="pt-BR" sz="1400">
+                          <a:solidFill>
+                            <a:srgbClr val="48A0C7"/>
+                          </a:solidFill>
+                          <a:effectLst/>
+                          <a:hlinkClick r:id="rId3"/>
+                        </a:rPr>
+                        <a:t>AlDahoul 2024 (SOTA)</a:t>
+                      </a:r>
+                      <a:r>
+                        <a:rPr lang="pt-BR" sz="1400">
+                          <a:effectLst/>
+                        </a:rPr>
+                        <a:t> · </a:t>
+                      </a:r>
+                      <a:r>
+                        <a:rPr lang="pt-BR" sz="1400">
+                          <a:solidFill>
+                            <a:srgbClr val="48A0C7"/>
+                          </a:solidFill>
+                          <a:effectLst/>
+                          <a:hlinkClick r:id="rId4"/>
+                        </a:rPr>
+                        <a:t>Lin 2022 (FairGRAPE)</a:t>
+                      </a:r>
+                      <a:endParaRPr lang="pt-BR" sz="1400">
+                        <a:effectLst/>
+                      </a:endParaRPr>
+                    </a:p>
+                  </a:txBody>
+                  <a:tcPr marL="10103" marR="10103" marT="10103" marB="10103" anchor="ctr"/>
+                </a:tc>
+                <a:extLst>
+                  <a:ext uri="{0D108BD9-81ED-4DB2-BD59-A6C34878D82A}">
+                    <a16:rowId xmlns:a16="http://schemas.microsoft.com/office/drawing/2014/main" val="1745330482"/>
+                  </a:ext>
+                </a:extLst>
+              </a:tr>
+              <a:tr h="456637">
+                <a:tc>
+                  <a:txBody>
+                    <a:bodyPr/>
+                    <a:lstStyle/>
+                    <a:p>
+                      <a:pPr>
+                        <a:buNone/>
+                      </a:pPr>
+                      <a:r>
+                        <a:rPr lang="pt-BR" sz="1400" b="1">
+                          <a:effectLst/>
+                        </a:rPr>
+                        <a:t>B — FR fairness</a:t>
+                      </a:r>
+                      <a:endParaRPr lang="pt-BR" sz="1400">
+                        <a:effectLst/>
+                      </a:endParaRPr>
+                    </a:p>
+                  </a:txBody>
+                  <a:tcPr marL="10103" marR="10103" marT="10103" marB="10103" anchor="ctr"/>
+                </a:tc>
+                <a:tc>
+                  <a:txBody>
+                    <a:bodyPr/>
+                    <a:lstStyle/>
+                    <a:p>
+                      <a:pPr>
+                        <a:buNone/>
+                      </a:pPr>
+                      <a:r>
+                        <a:rPr lang="pt-BR" sz="1400">
+                          <a:solidFill>
+                            <a:srgbClr val="48A0C7"/>
+                          </a:solidFill>
+                          <a:effectLst/>
+                          <a:hlinkClick r:id="rId5"/>
+                        </a:rPr>
+                        <a:t>Wang 2019 (RFW)</a:t>
+                      </a:r>
+                      <a:r>
+                        <a:rPr lang="pt-BR" sz="1400">
+                          <a:effectLst/>
+                        </a:rPr>
+                        <a:t> · </a:t>
+                      </a:r>
+                      <a:r>
+                        <a:rPr lang="pt-BR" sz="1400">
+                          <a:solidFill>
+                            <a:srgbClr val="48A0C7"/>
+                          </a:solidFill>
+                          <a:effectLst/>
+                          <a:hlinkClick r:id="rId6"/>
+                        </a:rPr>
+                        <a:t>Robinson 2020 (BFW)</a:t>
+                      </a:r>
+                      <a:r>
+                        <a:rPr lang="pt-BR" sz="1400">
+                          <a:effectLst/>
+                        </a:rPr>
+                        <a:t> · </a:t>
+                      </a:r>
+                      <a:r>
+                        <a:rPr lang="pt-BR" sz="1400">
+                          <a:solidFill>
+                            <a:srgbClr val="48A0C7"/>
+                          </a:solidFill>
+                          <a:effectLst/>
+                          <a:hlinkClick r:id="rId7"/>
+                        </a:rPr>
+                        <a:t>Grother 2019 (NIST)</a:t>
+                      </a:r>
+                      <a:r>
+                        <a:rPr lang="pt-BR" sz="1400">
+                          <a:effectLst/>
+                        </a:rPr>
+                        <a:t> · </a:t>
+                      </a:r>
+                      <a:r>
+                        <a:rPr lang="pt-BR" sz="1400">
+                          <a:solidFill>
+                            <a:srgbClr val="48A0C7"/>
+                          </a:solidFill>
+                          <a:effectLst/>
+                          <a:hlinkClick r:id="rId8"/>
+                        </a:rPr>
+                        <a:t>Neto 2025</a:t>
+                      </a:r>
+                      <a:endParaRPr lang="pt-BR" sz="1400">
+                        <a:effectLst/>
+                      </a:endParaRPr>
+                    </a:p>
+                  </a:txBody>
+                  <a:tcPr marL="10103" marR="10103" marT="10103" marB="10103" anchor="ctr"/>
+                </a:tc>
+                <a:extLst>
+                  <a:ext uri="{0D108BD9-81ED-4DB2-BD59-A6C34878D82A}">
+                    <a16:rowId xmlns:a16="http://schemas.microsoft.com/office/drawing/2014/main" val="1216747291"/>
+                  </a:ext>
+                </a:extLst>
+              </a:tr>
+              <a:tr h="674853">
+                <a:tc>
+                  <a:txBody>
+                    <a:bodyPr/>
+                    <a:lstStyle/>
+                    <a:p>
+                      <a:pPr>
+                        <a:buNone/>
+                      </a:pPr>
+                      <a:r>
+                        <a:rPr lang="pt-BR" sz="1400" b="1" dirty="0">
+                          <a:effectLst/>
+                        </a:rPr>
+                        <a:t>C — </a:t>
+                      </a:r>
+                      <a:r>
+                        <a:rPr lang="pt-BR" sz="1400" b="1" dirty="0" err="1">
+                          <a:effectLst/>
+                        </a:rPr>
+                        <a:t>Skin</a:t>
+                      </a:r>
+                      <a:r>
+                        <a:rPr lang="pt-BR" sz="1400" b="1" dirty="0">
+                          <a:effectLst/>
+                        </a:rPr>
+                        <a:t> </a:t>
+                      </a:r>
+                      <a:r>
+                        <a:rPr lang="pt-BR" sz="1400" b="1" dirty="0" err="1">
+                          <a:effectLst/>
+                        </a:rPr>
+                        <a:t>tone</a:t>
+                      </a:r>
+                      <a:endParaRPr lang="pt-BR" sz="1400" dirty="0">
+                        <a:effectLst/>
+                      </a:endParaRPr>
+                    </a:p>
+                  </a:txBody>
+                  <a:tcPr marL="10103" marR="10103" marT="10103" marB="10103" anchor="ctr"/>
+                </a:tc>
+                <a:tc>
+                  <a:txBody>
+                    <a:bodyPr/>
+                    <a:lstStyle/>
+                    <a:p>
+                      <a:pPr>
+                        <a:buNone/>
+                      </a:pPr>
+                      <a:r>
+                        <a:rPr lang="pt-BR" sz="1400">
+                          <a:solidFill>
+                            <a:srgbClr val="48A0C7"/>
+                          </a:solidFill>
+                          <a:effectLst/>
+                          <a:hlinkClick r:id="rId9"/>
+                        </a:rPr>
+                        <a:t>Buolamwini 2018</a:t>
+                      </a:r>
+                      <a:r>
+                        <a:rPr lang="pt-BR" sz="1400">
+                          <a:effectLst/>
+                        </a:rPr>
+                        <a:t> · </a:t>
+                      </a:r>
+                      <a:r>
+                        <a:rPr lang="pt-BR" sz="1400">
+                          <a:solidFill>
+                            <a:srgbClr val="48A0C7"/>
+                          </a:solidFill>
+                          <a:effectLst/>
+                          <a:hlinkClick r:id="rId10"/>
+                        </a:rPr>
+                        <a:t>Hazirbas 2021</a:t>
+                      </a:r>
+                      <a:r>
+                        <a:rPr lang="pt-BR" sz="1400">
+                          <a:effectLst/>
+                        </a:rPr>
+                        <a:t> · </a:t>
+                      </a:r>
+                      <a:r>
+                        <a:rPr lang="pt-BR" sz="1400">
+                          <a:solidFill>
+                            <a:srgbClr val="48A0C7"/>
+                          </a:solidFill>
+                          <a:effectLst/>
+                          <a:hlinkClick r:id="rId11"/>
+                        </a:rPr>
+                        <a:t>Schumann 2023 (MST)</a:t>
+                      </a:r>
+                      <a:r>
+                        <a:rPr lang="pt-BR" sz="1400">
+                          <a:effectLst/>
+                        </a:rPr>
+                        <a:t> · </a:t>
+                      </a:r>
+                      <a:r>
+                        <a:rPr lang="pt-BR" sz="1400">
+                          <a:solidFill>
+                            <a:srgbClr val="48A0C7"/>
+                          </a:solidFill>
+                          <a:effectLst/>
+                          <a:hlinkClick r:id="rId12"/>
+                        </a:rPr>
+                        <a:t>Lafargue 2025</a:t>
+                      </a:r>
+                      <a:endParaRPr lang="pt-BR" sz="1400">
+                        <a:effectLst/>
+                      </a:endParaRPr>
+                    </a:p>
+                  </a:txBody>
+                  <a:tcPr marL="10103" marR="10103" marT="10103" marB="10103" anchor="ctr"/>
+                </a:tc>
+                <a:extLst>
+                  <a:ext uri="{0D108BD9-81ED-4DB2-BD59-A6C34878D82A}">
+                    <a16:rowId xmlns:a16="http://schemas.microsoft.com/office/drawing/2014/main" val="149015989"/>
+                  </a:ext>
+                </a:extLst>
+              </a:tr>
+              <a:tr h="893069">
+                <a:tc>
+                  <a:txBody>
+                    <a:bodyPr/>
+                    <a:lstStyle/>
+                    <a:p>
+                      <a:pPr>
+                        <a:buNone/>
+                      </a:pPr>
+                      <a:r>
+                        <a:rPr lang="pt-BR" sz="1400" b="1">
+                          <a:effectLst/>
+                        </a:rPr>
+                        <a:t>D — Mitigação</a:t>
+                      </a:r>
+                      <a:endParaRPr lang="pt-BR" sz="1400">
+                        <a:effectLst/>
+                      </a:endParaRPr>
+                    </a:p>
+                  </a:txBody>
+                  <a:tcPr marL="10103" marR="10103" marT="10103" marB="10103" anchor="ctr"/>
+                </a:tc>
+                <a:tc>
+                  <a:txBody>
+                    <a:bodyPr/>
+                    <a:lstStyle/>
+                    <a:p>
+                      <a:pPr>
+                        <a:buNone/>
+                      </a:pPr>
+                      <a:r>
+                        <a:rPr lang="pt-BR" sz="1400">
+                          <a:solidFill>
+                            <a:srgbClr val="48A0C7"/>
+                          </a:solidFill>
+                          <a:effectLst/>
+                          <a:hlinkClick r:id="rId13"/>
+                        </a:rPr>
+                        <a:t>Park 2022 (FSCL)</a:t>
+                      </a:r>
+                      <a:r>
+                        <a:rPr lang="pt-BR" sz="1400">
+                          <a:effectLst/>
+                        </a:rPr>
+                        <a:t> · </a:t>
+                      </a:r>
+                      <a:r>
+                        <a:rPr lang="pt-BR" sz="1400">
+                          <a:solidFill>
+                            <a:srgbClr val="48A0C7"/>
+                          </a:solidFill>
+                          <a:effectLst/>
+                          <a:hlinkClick r:id="rId14"/>
+                        </a:rPr>
+                        <a:t>Sagawa 2020 (Group DRO)</a:t>
+                      </a:r>
+                      <a:r>
+                        <a:rPr lang="pt-BR" sz="1400">
+                          <a:effectLst/>
+                        </a:rPr>
+                        <a:t> · </a:t>
+                      </a:r>
+                      <a:r>
+                        <a:rPr lang="pt-BR" sz="1400">
+                          <a:solidFill>
+                            <a:srgbClr val="48A0C7"/>
+                          </a:solidFill>
+                          <a:effectLst/>
+                          <a:hlinkClick r:id="rId15"/>
+                        </a:rPr>
+                        <a:t>Manzoor 2024 (FineFACE)</a:t>
+                      </a:r>
+                      <a:r>
+                        <a:rPr lang="pt-BR" sz="1400">
+                          <a:effectLst/>
+                        </a:rPr>
+                        <a:t> · </a:t>
+                      </a:r>
+                      <a:r>
+                        <a:rPr lang="pt-BR" sz="1400">
+                          <a:solidFill>
+                            <a:srgbClr val="48A0C7"/>
+                          </a:solidFill>
+                          <a:effectLst/>
+                          <a:hlinkClick r:id="rId16"/>
+                        </a:rPr>
+                        <a:t>Bhaskaruni 2019</a:t>
+                      </a:r>
+                      <a:r>
+                        <a:rPr lang="pt-BR" sz="1400">
+                          <a:effectLst/>
+                        </a:rPr>
+                        <a:t> · </a:t>
+                      </a:r>
+                      <a:r>
+                        <a:rPr lang="pt-BR" sz="1400">
+                          <a:solidFill>
+                            <a:srgbClr val="48A0C7"/>
+                          </a:solidFill>
+                          <a:effectLst/>
+                          <a:hlinkClick r:id="rId17"/>
+                        </a:rPr>
+                        <a:t>Dehdashtian 2024</a:t>
+                      </a:r>
+                      <a:endParaRPr lang="pt-BR" sz="1400">
+                        <a:effectLst/>
+                      </a:endParaRPr>
+                    </a:p>
+                  </a:txBody>
+                  <a:tcPr marL="10103" marR="10103" marT="10103" marB="10103" anchor="ctr"/>
+                </a:tc>
+                <a:extLst>
+                  <a:ext uri="{0D108BD9-81ED-4DB2-BD59-A6C34878D82A}">
+                    <a16:rowId xmlns:a16="http://schemas.microsoft.com/office/drawing/2014/main" val="3228955285"/>
+                  </a:ext>
+                </a:extLst>
+              </a:tr>
+              <a:tr h="456637">
+                <a:tc>
+                  <a:txBody>
+                    <a:bodyPr/>
+                    <a:lstStyle/>
+                    <a:p>
+                      <a:pPr>
+                        <a:buNone/>
+                      </a:pPr>
+                      <a:r>
+                        <a:rPr lang="pt-BR" sz="1400" b="1">
+                          <a:effectLst/>
+                        </a:rPr>
+                        <a:t>E — Auditoria/metodologia</a:t>
+                      </a:r>
+                      <a:endParaRPr lang="pt-BR" sz="1400">
+                        <a:effectLst/>
+                      </a:endParaRPr>
+                    </a:p>
+                  </a:txBody>
+                  <a:tcPr marL="10103" marR="10103" marT="10103" marB="10103" anchor="ctr"/>
+                </a:tc>
+                <a:tc>
+                  <a:txBody>
+                    <a:bodyPr/>
+                    <a:lstStyle/>
+                    <a:p>
+                      <a:pPr>
+                        <a:buNone/>
+                      </a:pPr>
+                      <a:r>
+                        <a:rPr lang="pt-BR" sz="1400">
+                          <a:solidFill>
+                            <a:srgbClr val="48A0C7"/>
+                          </a:solidFill>
+                          <a:effectLst/>
+                          <a:hlinkClick r:id="rId18"/>
+                        </a:rPr>
+                        <a:t>Dominguez 2024 (DSAP)</a:t>
+                      </a:r>
+                      <a:r>
+                        <a:rPr lang="pt-BR" sz="1400">
+                          <a:effectLst/>
+                        </a:rPr>
+                        <a:t> · </a:t>
+                      </a:r>
+                      <a:r>
+                        <a:rPr lang="pt-BR" sz="1400">
+                          <a:solidFill>
+                            <a:srgbClr val="48A0C7"/>
+                          </a:solidFill>
+                          <a:effectLst/>
+                          <a:hlinkClick r:id="rId19"/>
+                        </a:rPr>
+                        <a:t>Mehrabi 2021 (survey)</a:t>
+                      </a:r>
+                      <a:r>
+                        <a:rPr lang="pt-BR" sz="1400">
+                          <a:effectLst/>
+                        </a:rPr>
+                        <a:t> · </a:t>
+                      </a:r>
+                      <a:r>
+                        <a:rPr lang="pt-BR" sz="1400">
+                          <a:solidFill>
+                            <a:srgbClr val="48A0C7"/>
+                          </a:solidFill>
+                          <a:effectLst/>
+                          <a:hlinkClick r:id="rId20"/>
+                        </a:rPr>
+                        <a:t>Kotwal 2025 (survey)</a:t>
+                      </a:r>
+                      <a:endParaRPr lang="pt-BR" sz="1400">
+                        <a:effectLst/>
+                      </a:endParaRPr>
+                    </a:p>
+                  </a:txBody>
+                  <a:tcPr marL="10103" marR="10103" marT="10103" marB="10103" anchor="ctr"/>
+                </a:tc>
+                <a:extLst>
+                  <a:ext uri="{0D108BD9-81ED-4DB2-BD59-A6C34878D82A}">
+                    <a16:rowId xmlns:a16="http://schemas.microsoft.com/office/drawing/2014/main" val="2269658635"/>
+                  </a:ext>
+                </a:extLst>
+              </a:tr>
+              <a:tr h="674853">
+                <a:tc>
+                  <a:txBody>
+                    <a:bodyPr/>
+                    <a:lstStyle/>
+                    <a:p>
+                      <a:pPr>
+                        <a:buNone/>
+                      </a:pPr>
+                      <a:r>
+                        <a:rPr lang="pt-BR" sz="1400" b="1">
+                          <a:effectLst/>
+                        </a:rPr>
+                        <a:t>F — Fundamentação</a:t>
+                      </a:r>
+                      <a:endParaRPr lang="pt-BR" sz="1400">
+                        <a:effectLst/>
+                      </a:endParaRPr>
+                    </a:p>
+                  </a:txBody>
+                  <a:tcPr marL="10103" marR="10103" marT="10103" marB="10103" anchor="ctr"/>
+                </a:tc>
+                <a:tc>
+                  <a:txBody>
+                    <a:bodyPr/>
+                    <a:lstStyle/>
+                    <a:p>
+                      <a:pPr>
+                        <a:buNone/>
+                      </a:pPr>
+                      <a:r>
+                        <a:rPr lang="pt-BR" sz="1400">
+                          <a:solidFill>
+                            <a:srgbClr val="48A0C7"/>
+                          </a:solidFill>
+                          <a:effectLst/>
+                          <a:hlinkClick r:id="rId21"/>
+                        </a:rPr>
+                        <a:t>Fuentes 2019 (AAPA)</a:t>
+                      </a:r>
+                      <a:r>
+                        <a:rPr lang="pt-BR" sz="1400">
+                          <a:effectLst/>
+                        </a:rPr>
+                        <a:t> · </a:t>
+                      </a:r>
+                      <a:r>
+                        <a:rPr lang="pt-BR" sz="1400">
+                          <a:solidFill>
+                            <a:srgbClr val="48A0C7"/>
+                          </a:solidFill>
+                          <a:effectLst/>
+                          <a:hlinkClick r:id="rId22"/>
+                        </a:rPr>
+                        <a:t>Lewontin 1972</a:t>
+                      </a:r>
+                      <a:r>
+                        <a:rPr lang="pt-BR" sz="1400">
+                          <a:effectLst/>
+                        </a:rPr>
+                        <a:t> · </a:t>
+                      </a:r>
+                      <a:r>
+                        <a:rPr lang="pt-BR" sz="1400">
+                          <a:solidFill>
+                            <a:srgbClr val="48A0C7"/>
+                          </a:solidFill>
+                          <a:effectLst/>
+                          <a:hlinkClick r:id="rId23"/>
+                        </a:rPr>
+                        <a:t>Fitzpatrick 1988</a:t>
+                      </a:r>
+                      <a:r>
+                        <a:rPr lang="pt-BR" sz="1400">
+                          <a:effectLst/>
+                        </a:rPr>
+                        <a:t> · </a:t>
+                      </a:r>
+                      <a:r>
+                        <a:rPr lang="pt-BR" sz="1400">
+                          <a:solidFill>
+                            <a:srgbClr val="48A0C7"/>
+                          </a:solidFill>
+                          <a:effectLst/>
+                          <a:hlinkClick r:id="rId24"/>
+                        </a:rPr>
+                        <a:t>Massey &amp; Martin 2003</a:t>
+                      </a:r>
+                      <a:endParaRPr lang="pt-BR" sz="1400">
+                        <a:effectLst/>
+                      </a:endParaRPr>
+                    </a:p>
+                  </a:txBody>
+                  <a:tcPr marL="10103" marR="10103" marT="10103" marB="10103" anchor="ctr"/>
+                </a:tc>
+                <a:extLst>
+                  <a:ext uri="{0D108BD9-81ED-4DB2-BD59-A6C34878D82A}">
+                    <a16:rowId xmlns:a16="http://schemas.microsoft.com/office/drawing/2014/main" val="2693752794"/>
+                  </a:ext>
+                </a:extLst>
+              </a:tr>
+              <a:tr h="674853">
+                <a:tc>
+                  <a:txBody>
+                    <a:bodyPr/>
+                    <a:lstStyle/>
+                    <a:p>
+                      <a:pPr>
+                        <a:buNone/>
+                      </a:pPr>
+                      <a:r>
+                        <a:rPr lang="pt-BR" sz="1400" b="1" dirty="0">
+                          <a:effectLst/>
+                        </a:rPr>
+                        <a:t>G — Mecanismos ML</a:t>
+                      </a:r>
+                      <a:endParaRPr lang="pt-BR" sz="1400" dirty="0">
+                        <a:effectLst/>
+                      </a:endParaRPr>
+                    </a:p>
+                  </a:txBody>
+                  <a:tcPr marL="10103" marR="10103" marT="10103" marB="10103" anchor="ctr"/>
+                </a:tc>
+                <a:tc>
+                  <a:txBody>
+                    <a:bodyPr/>
+                    <a:lstStyle/>
+                    <a:p>
+                      <a:pPr>
+                        <a:buNone/>
+                      </a:pPr>
+                      <a:r>
+                        <a:rPr lang="pt-BR" sz="1400" dirty="0" err="1">
+                          <a:solidFill>
+                            <a:srgbClr val="48A0C7"/>
+                          </a:solidFill>
+                          <a:effectLst/>
+                          <a:hlinkClick r:id="rId25"/>
+                        </a:rPr>
+                        <a:t>Hardt</a:t>
+                      </a:r>
+                      <a:r>
+                        <a:rPr lang="pt-BR" sz="1400" dirty="0">
+                          <a:solidFill>
+                            <a:srgbClr val="48A0C7"/>
+                          </a:solidFill>
+                          <a:effectLst/>
+                          <a:hlinkClick r:id="rId25"/>
+                        </a:rPr>
+                        <a:t> 2016</a:t>
+                      </a:r>
+                      <a:r>
+                        <a:rPr lang="pt-BR" sz="1400" dirty="0">
+                          <a:effectLst/>
+                        </a:rPr>
+                        <a:t> · </a:t>
+                      </a:r>
+                      <a:r>
+                        <a:rPr lang="pt-BR" sz="1400" dirty="0">
+                          <a:solidFill>
+                            <a:srgbClr val="48A0C7"/>
+                          </a:solidFill>
+                          <a:effectLst/>
+                          <a:hlinkClick r:id="rId26"/>
+                        </a:rPr>
+                        <a:t>Perez 2018 (</a:t>
+                      </a:r>
+                      <a:r>
+                        <a:rPr lang="pt-BR" sz="1400" dirty="0" err="1">
+                          <a:solidFill>
+                            <a:srgbClr val="48A0C7"/>
+                          </a:solidFill>
+                          <a:effectLst/>
+                          <a:hlinkClick r:id="rId26"/>
+                        </a:rPr>
+                        <a:t>FiLM</a:t>
+                      </a:r>
+                      <a:r>
+                        <a:rPr lang="pt-BR" sz="1400" dirty="0">
+                          <a:solidFill>
+                            <a:srgbClr val="48A0C7"/>
+                          </a:solidFill>
+                          <a:effectLst/>
+                          <a:hlinkClick r:id="rId26"/>
+                        </a:rPr>
+                        <a:t>)</a:t>
+                      </a:r>
+                      <a:r>
+                        <a:rPr lang="pt-BR" sz="1400" dirty="0">
+                          <a:effectLst/>
+                        </a:rPr>
+                        <a:t> · </a:t>
+                      </a:r>
+                      <a:r>
+                        <a:rPr lang="pt-BR" sz="1400" dirty="0">
+                          <a:solidFill>
+                            <a:srgbClr val="48A0C7"/>
+                          </a:solidFill>
+                          <a:effectLst/>
+                          <a:hlinkClick r:id="rId27"/>
+                        </a:rPr>
+                        <a:t>Zemel 2013 (LFR)</a:t>
+                      </a:r>
+                      <a:r>
+                        <a:rPr lang="pt-BR" sz="1400" dirty="0">
+                          <a:effectLst/>
+                        </a:rPr>
+                        <a:t> · </a:t>
+                      </a:r>
+                      <a:r>
+                        <a:rPr lang="pt-BR" sz="1400" dirty="0">
+                          <a:solidFill>
+                            <a:srgbClr val="48A0C7"/>
+                          </a:solidFill>
+                          <a:effectLst/>
+                          <a:hlinkClick r:id="rId28"/>
+                        </a:rPr>
+                        <a:t>Madras 2018 (LAFTR)</a:t>
+                      </a:r>
+                      <a:r>
+                        <a:rPr lang="pt-BR" sz="1400" dirty="0">
+                          <a:effectLst/>
+                        </a:rPr>
+                        <a:t> · </a:t>
+                      </a:r>
+                      <a:r>
+                        <a:rPr lang="pt-BR" sz="1400" dirty="0">
+                          <a:solidFill>
+                            <a:srgbClr val="48A0C7"/>
+                          </a:solidFill>
+                          <a:effectLst/>
+                          <a:hlinkClick r:id="rId29"/>
+                        </a:rPr>
+                        <a:t>Zhang 2018 (Adversarial)</a:t>
+                      </a:r>
+                      <a:r>
+                        <a:rPr lang="pt-BR" sz="1400" dirty="0">
+                          <a:effectLst/>
+                        </a:rPr>
+                        <a:t> · </a:t>
+                      </a:r>
+                      <a:r>
+                        <a:rPr lang="pt-BR" sz="1400" dirty="0" err="1">
+                          <a:solidFill>
+                            <a:srgbClr val="48A0C7"/>
+                          </a:solidFill>
+                          <a:effectLst/>
+                          <a:hlinkClick r:id="rId30"/>
+                        </a:rPr>
+                        <a:t>Kleinberg</a:t>
+                      </a:r>
+                      <a:r>
+                        <a:rPr lang="pt-BR" sz="1400" dirty="0">
+                          <a:solidFill>
+                            <a:srgbClr val="48A0C7"/>
+                          </a:solidFill>
+                          <a:effectLst/>
+                          <a:hlinkClick r:id="rId30"/>
+                        </a:rPr>
+                        <a:t> 2017</a:t>
+                      </a:r>
+                      <a:endParaRPr lang="pt-BR" sz="1400" dirty="0">
+                        <a:effectLst/>
+                      </a:endParaRPr>
+                    </a:p>
+                  </a:txBody>
+                  <a:tcPr marL="10103" marR="10103" marT="10103" marB="10103" anchor="ctr"/>
+                </a:tc>
+                <a:extLst>
+                  <a:ext uri="{0D108BD9-81ED-4DB2-BD59-A6C34878D82A}">
+                    <a16:rowId xmlns:a16="http://schemas.microsoft.com/office/drawing/2014/main" val="4151081207"/>
+                  </a:ext>
+                </a:extLst>
+              </a:tr>
+            </a:tbl>
+          </a:graphicData>
+        </a:graphic>
+      </p:graphicFrame>
+    </p:spTree>
+    <p:extLst>
+      <p:ext uri="{BB962C8B-B14F-4D97-AF65-F5344CB8AC3E}">
+        <p14:creationId xmlns:p14="http://schemas.microsoft.com/office/powerpoint/2010/main" val="1453582692"/>
+      </p:ext>
+    </p:extLst>
+  </p:cSld>
+  <p:clrMapOvr>
+    <a:masterClrMapping/>
+  </p:clrMapOvr>
+</p:sld>
+</file>
+
 <file path=ppt/slides/slide4.xml><?xml version="1.0" encoding="utf-8"?>
 <p:sld xmlns:a="http://schemas.openxmlformats.org/drawingml/2006/main" xmlns:r="http://schemas.openxmlformats.org/officeDocument/2006/relationships" xmlns:p="http://schemas.openxmlformats.org/presentationml/2006/main">
   <p:cSld>
@@ -18619,14 +19996,14 @@
           <p:nvPr>
             <p:extLst>
               <p:ext uri="{D42A27DB-BD31-4B8C-83A1-F6EECF244321}">
-                <p14:modId xmlns:p14="http://schemas.microsoft.com/office/powerpoint/2010/main" val="833417514"/>
+                <p14:modId xmlns:p14="http://schemas.microsoft.com/office/powerpoint/2010/main" val="3010668842"/>
               </p:ext>
             </p:extLst>
           </p:nvPr>
         </p:nvGraphicFramePr>
         <p:xfrm>
           <a:off x="457200" y="1371600"/>
-          <a:ext cx="11430000" cy="4937760"/>
+          <a:ext cx="11430000" cy="4232364"/>
         </p:xfrm>
         <a:graphic>
           <a:graphicData uri="http://schemas.openxmlformats.org/drawingml/2006/table">
@@ -18657,13 +20034,18 @@
                     <a:lstStyle/>
                     <a:p>
                       <a:r>
-                        <a:rPr sz="1600" b="1">
+                        <a:rPr sz="1600" b="1" dirty="0" err="1">
                           <a:solidFill>
                             <a:srgbClr val="FFFFFF"/>
                           </a:solidFill>
                         </a:rPr>
                         <a:t>Dimensão</a:t>
                       </a:r>
+                      <a:endParaRPr sz="1600" b="1" dirty="0">
+                        <a:solidFill>
+                          <a:srgbClr val="FFFFFF"/>
+                        </a:solidFill>
+                      </a:endParaRPr>
                     </a:p>
                   </a:txBody>
                   <a:tcPr>
@@ -18981,56 +20363,7 @@
                     <a:lstStyle/>
                     <a:p>
                       <a:r>
-                        <a:rPr sz="1500">
-                          <a:solidFill>
-                            <a:srgbClr val="3D424E"/>
-                          </a:solidFill>
-                        </a:rPr>
-                        <a:t>Critério de sucesso</a:t>
-                      </a:r>
-                    </a:p>
-                  </a:txBody>
-                  <a:tcPr>
-                    <a:solidFill>
-                      <a:srgbClr val="E8EAED"/>
-                    </a:solidFill>
-                  </a:tcPr>
-                </a:tc>
-                <a:tc>
-                  <a:txBody>
-                    <a:bodyPr/>
-                    <a:lstStyle/>
-                    <a:p>
-                      <a:r>
-                        <a:rPr sz="1500">
-                          <a:solidFill>
-                            <a:srgbClr val="3D424E"/>
-                          </a:solidFill>
-                        </a:rPr>
-                        <a:t>Decomposição: irredutível vs redutível</a:t>
-                      </a:r>
-                    </a:p>
-                  </a:txBody>
-                  <a:tcPr>
-                    <a:solidFill>
-                      <a:srgbClr val="E8EAED"/>
-                    </a:solidFill>
-                  </a:tcPr>
-                </a:tc>
-                <a:extLst>
-                  <a:ext uri="{0D108BD9-81ED-4DB2-BD59-A6C34878D82A}">
-                    <a16:rowId xmlns:a16="http://schemas.microsoft.com/office/drawing/2014/main" val="10004"/>
-                  </a:ext>
-                </a:extLst>
-              </a:tr>
-              <a:tr h="705394">
-                <a:tc>
-                  <a:txBody>
-                    <a:bodyPr/>
-                    <a:lstStyle/>
-                    <a:p>
-                      <a:r>
-                        <a:rPr sz="1500">
+                        <a:rPr sz="1500" dirty="0">
                           <a:solidFill>
                             <a:srgbClr val="3D424E"/>
                           </a:solidFill>
@@ -19041,7 +20374,7 @@
                   </a:txBody>
                   <a:tcPr>
                     <a:solidFill>
-                      <a:srgbClr val="FFFFFF"/>
+                      <a:srgbClr val="E8EAED"/>
                     </a:solidFill>
                   </a:tcPr>
                 </a:tc>
@@ -19142,35 +20475,72 @@
                   </a:txBody>
                   <a:tcPr>
                     <a:solidFill>
-                      <a:srgbClr val="FFFFFF"/>
+                      <a:srgbClr val="E8EAED"/>
                     </a:solidFill>
                   </a:tcPr>
                 </a:tc>
                 <a:extLst>
                   <a:ext uri="{0D108BD9-81ED-4DB2-BD59-A6C34878D82A}">
-                    <a16:rowId xmlns:a16="http://schemas.microsoft.com/office/drawing/2014/main" val="10005"/>
+                    <a16:rowId xmlns:a16="http://schemas.microsoft.com/office/drawing/2014/main" val="10004"/>
                   </a:ext>
                 </a:extLst>
               </a:tr>
-              <a:tr h="705396">
+              <a:tr h="705394">
                 <a:tc>
                   <a:txBody>
                     <a:bodyPr/>
                     <a:lstStyle/>
                     <a:p>
                       <a:r>
-                        <a:rPr sz="1500">
+                        <a:rPr sz="1500" dirty="0" err="1">
                           <a:solidFill>
                             <a:srgbClr val="3D424E"/>
                           </a:solidFill>
                         </a:rPr>
-                        <a:t>Validado na reunião</a:t>
+                        <a:t>Validado</a:t>
                       </a:r>
+                      <a:r>
+                        <a:rPr sz="1500" dirty="0">
+                          <a:solidFill>
+                            <a:srgbClr val="3D424E"/>
+                          </a:solidFill>
+                        </a:rPr>
+                        <a:t> </a:t>
+                      </a:r>
+                      <a:r>
+                        <a:rPr sz="1500" dirty="0" err="1">
+                          <a:solidFill>
+                            <a:srgbClr val="3D424E"/>
+                          </a:solidFill>
+                        </a:rPr>
+                        <a:t>na</a:t>
+                      </a:r>
+                      <a:r>
+                        <a:rPr sz="1500" dirty="0">
+                          <a:solidFill>
+                            <a:srgbClr val="3D424E"/>
+                          </a:solidFill>
+                        </a:rPr>
+                        <a:t> </a:t>
+                      </a:r>
+                      <a:r>
+                        <a:rPr sz="1500" dirty="0" err="1">
+                          <a:solidFill>
+                            <a:srgbClr val="3D424E"/>
+                          </a:solidFill>
+                        </a:rPr>
+                        <a:t>reunião</a:t>
+                      </a:r>
+                      <a:endParaRPr sz="1500" dirty="0">
+                        <a:solidFill>
+                          <a:srgbClr val="3D424E"/>
+                        </a:solidFill>
+                      </a:endParaRPr>
                     </a:p>
                   </a:txBody>
                   <a:tcPr>
                     <a:solidFill>
-                      <a:srgbClr val="E8EAED"/>
+                      <a:srgbClr val="FFFFFF"/>
                     </a:solidFill>
                   </a:tcPr>
                 </a:tc>
@@ -19276,13 +20646,13 @@
                   </a:txBody>
                   <a:tcPr>
                     <a:solidFill>
-                      <a:srgbClr val="E8EAED"/>
+                      <a:srgbClr val="FFFFFF"/>
                     </a:solidFill>
                   </a:tcPr>
                 </a:tc>
                 <a:extLst>
                   <a:ext uri="{0D108BD9-81ED-4DB2-BD59-A6C34878D82A}">
-                    <a16:rowId xmlns:a16="http://schemas.microsoft.com/office/drawing/2014/main" val="10006"/>
+                    <a16:rowId xmlns:a16="http://schemas.microsoft.com/office/drawing/2014/main" val="10005"/>
                   </a:ext>
                 </a:extLst>
               </a:tr>
@@ -20106,7 +21476,7 @@
         <p:spPr>
           <a:xfrm>
             <a:off x="548640" y="1371600"/>
-            <a:ext cx="11247120" cy="3406061"/>
+            <a:ext cx="11247120" cy="3770263"/>
           </a:xfrm>
           <a:prstGeom prst="rect">
             <a:avLst/>
@@ -20130,8 +21500,8 @@
               </a:defRPr>
             </a:pPr>
             <a:r>
-              <a:rPr dirty="0" err="1"/>
-              <a:t>Executei</a:t>
+              <a:rPr lang="pt-BR" dirty="0"/>
+              <a:t>Executada</a:t>
             </a:r>
             <a:r>
               <a:rPr dirty="0"/>
@@ -20203,12 +21573,20 @@
               </a:defRPr>
             </a:pPr>
             <a:r>
-              <a:rPr dirty="0" err="1"/>
-              <a:t>Adicionei</a:t>
-            </a:r>
-            <a:r>
-              <a:rPr dirty="0"/>
-              <a:t> 6 </a:t>
+              <a:rPr lang="pt-BR" dirty="0"/>
+              <a:t>Adicionadas</a:t>
+            </a:r>
+            <a:r>
+              <a:rPr dirty="0"/>
+              <a:t> </a:t>
+            </a:r>
+            <a:r>
+              <a:rPr lang="pt-BR" dirty="0"/>
+              <a:t>7</a:t>
+            </a:r>
+            <a:r>
+              <a:rPr dirty="0"/>
+              <a:t> </a:t>
             </a:r>
             <a:r>
               <a:rPr dirty="0" err="1"/>
@@ -20232,11 +21610,11 @@
             </a:r>
             <a:r>
               <a:rPr dirty="0"/>
-              <a:t> de venues top da </a:t>
-            </a:r>
-            <a:r>
-              <a:rPr dirty="0" err="1"/>
-              <a:t>área</a:t>
+              <a:t> de venues </a:t>
+            </a:r>
+            <a:r>
+              <a:rPr lang="pt-BR" dirty="0" err="1"/>
+              <a:t>refencias</a:t>
             </a:r>
             <a:r>
               <a:rPr dirty="0"/>
@@ -20303,31 +21681,59 @@
               </a:defRPr>
             </a:pPr>
             <a:r>
-              <a:rPr dirty="0"/>
+              <a:rPr dirty="0">
+                <a:solidFill>
+                  <a:srgbClr val="00B050"/>
+                </a:solidFill>
+              </a:rPr>
               <a:t>• Perez et al. (AAAI 2018) — </a:t>
             </a:r>
             <a:r>
-              <a:rPr dirty="0" err="1"/>
+              <a:rPr dirty="0" err="1">
+                <a:solidFill>
+                  <a:srgbClr val="00B050"/>
+                </a:solidFill>
+              </a:rPr>
               <a:t>FiLM</a:t>
             </a:r>
             <a:r>
-              <a:rPr dirty="0"/>
+              <a:rPr dirty="0">
+                <a:solidFill>
+                  <a:srgbClr val="00B050"/>
+                </a:solidFill>
+              </a:rPr>
               <a:t>, </a:t>
             </a:r>
             <a:r>
-              <a:rPr dirty="0" err="1"/>
+              <a:rPr dirty="0" err="1">
+                <a:solidFill>
+                  <a:srgbClr val="00B050"/>
+                </a:solidFill>
+              </a:rPr>
               <a:t>mecanismo</a:t>
             </a:r>
             <a:r>
-              <a:rPr dirty="0"/>
+              <a:rPr dirty="0">
+                <a:solidFill>
+                  <a:srgbClr val="00B050"/>
+                </a:solidFill>
+              </a:rPr>
               <a:t> de </a:t>
             </a:r>
             <a:r>
-              <a:rPr dirty="0" err="1"/>
+              <a:rPr dirty="0" err="1">
+                <a:solidFill>
+                  <a:srgbClr val="00B050"/>
+                </a:solidFill>
+              </a:rPr>
               <a:t>condicionamento</a:t>
             </a:r>
             <a:r>
-              <a:rPr dirty="0"/>
+              <a:rPr dirty="0">
+                <a:solidFill>
+                  <a:srgbClr val="00B050"/>
+                </a:solidFill>
+              </a:rPr>
               <a:t> neural</a:t>
             </a:r>
           </a:p>
@@ -20343,7 +21749,11 @@
               </a:defRPr>
             </a:pPr>
             <a:r>
-              <a:rPr dirty="0"/>
+              <a:rPr dirty="0">
+                <a:solidFill>
+                  <a:srgbClr val="00B050"/>
+                </a:solidFill>
+              </a:rPr>
               <a:t>• Zemel et al. (ICML 2013, Test-of-Time Award 2023) — Fair Representation Learning</a:t>
             </a:r>
           </a:p>
@@ -20427,7 +21837,80 @@
               <a:rPr dirty="0" err="1"/>
               <a:t>impossibilidade</a:t>
             </a:r>
-            <a:endParaRPr dirty="0"/>
+            <a:endParaRPr lang="pt-BR" dirty="0"/>
+          </a:p>
+          <a:p>
+            <a:pPr lvl="1">
+              <a:spcAft>
+                <a:spcPts val="800"/>
+              </a:spcAft>
+              <a:defRPr sz="1700">
+                <a:solidFill>
+                  <a:srgbClr val="707682"/>
+                </a:solidFill>
+              </a:defRPr>
+            </a:pPr>
+            <a:r>
+              <a:rPr lang="pt-BR" dirty="0">
+                <a:solidFill>
+                  <a:srgbClr val="00B050"/>
+                </a:solidFill>
+              </a:rPr>
+              <a:t>• (adicionado hoje): </a:t>
+            </a:r>
+            <a:r>
+              <a:rPr lang="pt-BR" dirty="0" err="1">
+                <a:solidFill>
+                  <a:srgbClr val="00B050"/>
+                </a:solidFill>
+              </a:rPr>
+              <a:t>SkinToneNet</a:t>
+            </a:r>
+            <a:r>
+              <a:rPr lang="pt-BR" dirty="0">
+                <a:solidFill>
+                  <a:srgbClr val="00B050"/>
+                </a:solidFill>
+              </a:rPr>
+              <a:t> + STW </a:t>
+            </a:r>
+            <a:r>
+              <a:rPr lang="pt-BR" dirty="0" err="1">
+                <a:solidFill>
+                  <a:srgbClr val="00B050"/>
+                </a:solidFill>
+              </a:rPr>
+              <a:t>Dataset</a:t>
+            </a:r>
+            <a:r>
+              <a:rPr lang="pt-BR" dirty="0">
+                <a:solidFill>
+                  <a:srgbClr val="00B050"/>
+                </a:solidFill>
+              </a:rPr>
+              <a:t> (Pereira Matias, Costa, Neto &amp; Novello de Brito, 2026) - </a:t>
+            </a:r>
+            <a:r>
+              <a:rPr lang="pt-BR" dirty="0" err="1">
+                <a:solidFill>
+                  <a:srgbClr val="00B050"/>
+                </a:solidFill>
+              </a:rPr>
+              <a:t>SkinToneNet</a:t>
+            </a:r>
+            <a:r>
+              <a:rPr lang="pt-BR" dirty="0">
+                <a:solidFill>
+                  <a:srgbClr val="00B050"/>
+                </a:solidFill>
+              </a:rPr>
+              <a:t> </a:t>
+            </a:r>
+            <a:endParaRPr dirty="0">
+              <a:solidFill>
+                <a:srgbClr val="00B050"/>
+              </a:solidFill>
+            </a:endParaRPr>
           </a:p>
         </p:txBody>
       </p:sp>
@@ -20578,7 +22061,7 @@
         <p:spPr>
           <a:xfrm>
             <a:off x="548640" y="1371600"/>
-            <a:ext cx="11247120" cy="4683333"/>
+            <a:ext cx="11247120" cy="3452227"/>
           </a:xfrm>
           <a:prstGeom prst="rect">
             <a:avLst/>
@@ -20823,8 +22306,8 @@
               <a:t>código</a:t>
             </a:r>
             <a:r>
-              <a:rPr dirty="0"/>
-              <a:t>, seeds?</a:t>
+              <a:rPr lang="pt-BR" dirty="0"/>
+              <a:t>?</a:t>
             </a:r>
           </a:p>
           <a:p>
@@ -20839,64 +22322,8 @@
               </a:defRPr>
             </a:pPr>
             <a:r>
-              <a:rPr dirty="0"/>
-              <a:t>(c) </a:t>
-            </a:r>
-            <a:r>
-              <a:rPr dirty="0" err="1"/>
-              <a:t>Aplicabilidade</a:t>
-            </a:r>
-            <a:r>
-              <a:rPr dirty="0"/>
-              <a:t> </a:t>
-            </a:r>
-            <a:r>
-              <a:rPr dirty="0" err="1"/>
-              <a:t>ao</a:t>
-            </a:r>
-            <a:r>
-              <a:rPr dirty="0"/>
-              <a:t> </a:t>
-            </a:r>
-            <a:r>
-              <a:rPr dirty="0" err="1"/>
-              <a:t>nosso</a:t>
-            </a:r>
-            <a:r>
-              <a:rPr dirty="0"/>
-              <a:t> pipeline — </a:t>
-            </a:r>
-            <a:r>
-              <a:rPr dirty="0" err="1"/>
-              <a:t>onde</a:t>
-            </a:r>
-            <a:r>
-              <a:rPr dirty="0"/>
-              <a:t> </a:t>
-            </a:r>
-            <a:r>
-              <a:rPr dirty="0" err="1"/>
-              <a:t>funciona</a:t>
-            </a:r>
-            <a:r>
-              <a:rPr dirty="0"/>
-              <a:t> e </a:t>
-            </a:r>
-            <a:r>
-              <a:rPr dirty="0" err="1"/>
-              <a:t>onde</a:t>
-            </a:r>
-            <a:r>
-              <a:rPr dirty="0"/>
-              <a:t> </a:t>
-            </a:r>
-            <a:r>
-              <a:rPr dirty="0" err="1"/>
-              <a:t>falha</a:t>
-            </a:r>
-            <a:r>
-              <a:rPr dirty="0"/>
-              <a:t>?</a:t>
+              <a:rPr lang="pt-BR" dirty="0"/>
+              <a:t>(c) Aplicabilidade ao nosso pipeline — onde funciona e onde falha?</a:t>
             </a:r>
           </a:p>
           <a:p>
@@ -20946,6 +22373,19 @@
               <a:rPr dirty="0"/>
               <a:t>?</a:t>
             </a:r>
+            <a:r>
+              <a:rPr lang="pt-BR" dirty="0"/>
+              <a:t> Testes </a:t>
+            </a:r>
+            <a:r>
+              <a:rPr lang="pt-BR" dirty="0" err="1"/>
+              <a:t>estatisticos</a:t>
+            </a:r>
+            <a:r>
+              <a:rPr lang="pt-BR" dirty="0"/>
+              <a:t>?</a:t>
+            </a:r>
+            <a:endParaRPr dirty="0"/>
           </a:p>
           <a:p>
             <a:pPr lvl="1">
@@ -20996,171 +22436,6 @@
               </a:defRPr>
             </a:pPr>
             <a:endParaRPr lang="pt-BR" dirty="0"/>
-          </a:p>
-          <a:p>
-            <a:pPr>
-              <a:spcAft>
-                <a:spcPts val="800"/>
-              </a:spcAft>
-              <a:defRPr sz="2000" b="0">
-                <a:solidFill>
-                  <a:srgbClr val="3D424E"/>
-                </a:solidFill>
-              </a:defRPr>
-            </a:pPr>
-            <a:r>
-              <a:rPr lang="pt-BR" i="1" dirty="0"/>
-              <a:t>Observações:</a:t>
-            </a:r>
-            <a:endParaRPr i="1" dirty="0"/>
-          </a:p>
-          <a:p>
-            <a:pPr>
-              <a:spcAft>
-                <a:spcPts val="800"/>
-              </a:spcAft>
-              <a:defRPr sz="2000" b="0">
-                <a:solidFill>
-                  <a:srgbClr val="3D424E"/>
-                </a:solidFill>
-              </a:defRPr>
-            </a:pPr>
-            <a:r>
-              <a:rPr lang="pt-BR" i="1" dirty="0"/>
-              <a:t>- </a:t>
-            </a:r>
-            <a:r>
-              <a:rPr i="1" dirty="0" err="1"/>
-              <a:t>Adicionada</a:t>
-            </a:r>
-            <a:r>
-              <a:rPr i="1" dirty="0"/>
-              <a:t> </a:t>
-            </a:r>
-            <a:r>
-              <a:rPr i="1" dirty="0" err="1"/>
-              <a:t>nas</a:t>
-            </a:r>
-            <a:r>
-              <a:rPr i="1" dirty="0"/>
-              <a:t> 10 </a:t>
-            </a:r>
-            <a:r>
-              <a:rPr i="1" dirty="0" err="1"/>
-              <a:t>fichas</a:t>
-            </a:r>
-            <a:r>
-              <a:rPr i="1" dirty="0"/>
-              <a:t> </a:t>
-            </a:r>
-            <a:r>
-              <a:rPr i="1" dirty="0" err="1"/>
-              <a:t>centrais</a:t>
-            </a:r>
-            <a:r>
-              <a:rPr i="1" dirty="0"/>
-              <a:t> (</a:t>
-            </a:r>
-            <a:r>
-              <a:rPr i="1" dirty="0" err="1"/>
-              <a:t>lista</a:t>
-            </a:r>
-            <a:r>
-              <a:rPr i="1" dirty="0"/>
-              <a:t> de </a:t>
-            </a:r>
-            <a:r>
-              <a:rPr i="1" dirty="0" err="1"/>
-              <a:t>leitura</a:t>
-            </a:r>
-            <a:r>
-              <a:rPr i="1" dirty="0"/>
-              <a:t> </a:t>
-            </a:r>
-            <a:r>
-              <a:rPr i="1" dirty="0" err="1"/>
-              <a:t>prioritária</a:t>
-            </a:r>
-            <a:r>
-              <a:rPr i="1" dirty="0"/>
-              <a:t>).</a:t>
-            </a:r>
-          </a:p>
-          <a:p>
-            <a:pPr>
-              <a:spcAft>
-                <a:spcPts val="800"/>
-              </a:spcAft>
-              <a:defRPr sz="2000" b="0">
-                <a:solidFill>
-                  <a:srgbClr val="3D424E"/>
-                </a:solidFill>
-              </a:defRPr>
-            </a:pPr>
-            <a:r>
-              <a:rPr lang="pt-BR" i="1" dirty="0"/>
-              <a:t>- </a:t>
-            </a:r>
-            <a:r>
-              <a:rPr i="1" dirty="0"/>
-              <a:t>Vamos </a:t>
-            </a:r>
-            <a:r>
-              <a:rPr i="1" dirty="0" err="1"/>
-              <a:t>expandir</a:t>
-            </a:r>
-            <a:r>
-              <a:rPr i="1" dirty="0"/>
-              <a:t> para as </a:t>
-            </a:r>
-            <a:r>
-              <a:rPr i="1" dirty="0" err="1"/>
-              <a:t>outras</a:t>
-            </a:r>
-            <a:r>
-              <a:rPr i="1" dirty="0"/>
-              <a:t> 19 </a:t>
-            </a:r>
-            <a:r>
-              <a:rPr i="1" dirty="0" err="1"/>
-              <a:t>após</a:t>
-            </a:r>
-            <a:r>
-              <a:rPr i="1" dirty="0"/>
-              <a:t> </a:t>
-            </a:r>
-            <a:r>
-              <a:rPr i="1" dirty="0" err="1"/>
-              <a:t>aprovação</a:t>
-            </a:r>
-            <a:r>
-              <a:rPr i="1" dirty="0"/>
-              <a:t> </a:t>
-            </a:r>
-            <a:r>
-              <a:rPr i="1" dirty="0" err="1"/>
-              <a:t>conjunta</a:t>
-            </a:r>
-            <a:r>
-              <a:rPr i="1" dirty="0"/>
-              <a:t> da nova </a:t>
-            </a:r>
-            <a:r>
-              <a:rPr i="1" dirty="0" err="1"/>
-              <a:t>versão</a:t>
-            </a:r>
-            <a:r>
-              <a:rPr i="1" dirty="0"/>
-              <a:t> da </a:t>
-            </a:r>
-            <a:r>
-              <a:rPr i="1" dirty="0" err="1"/>
-              <a:t>tese</a:t>
-            </a:r>
-            <a:r>
-              <a:rPr i="1" dirty="0"/>
-              <a:t>.</a:t>
-            </a:r>
           </a:p>
         </p:txBody>
       </p:sp>

</xml_diff>